<commit_message>
Presentation: expand to 20 slides covering all assignment requirements
New slides: Method Comparison table (all 8 models, 3 metric categories),
Technical Challenges (sparsity, cold-start, scalability, pop bias),
Ethics & Social Implications (filter bubbles, privacy, transparency,
fairness, user autonomy), Future Work (hybrid, online learning, A/B,
debiasing). Enhanced: dataset slide with license/filtering/methodology,
each algorithm slide with strength/weakness/use-case, trade-off slide
with concrete numbered examples, Final Remarks with honest limitations
and cost/benefit framing.

Co-Authored-By: Claude Opus 4.6 <noreply@anthropic.com>
</commit_message>
<xml_diff>
--- a/CineMatch_Presentation.pptx
+++ b/CineMatch_Presentation.pptx
@@ -21,6 +21,10 @@
     <p:sldId id="269" r:id="rId20"/>
     <p:sldId id="270" r:id="rId21"/>
     <p:sldId id="271" r:id="rId22"/>
+    <p:sldId id="272" r:id="rId23"/>
+    <p:sldId id="273" r:id="rId24"/>
+    <p:sldId id="274" r:id="rId25"/>
+    <p:sldId id="275" r:id="rId26"/>
   </p:sldIdLst>
   <p:sldSz cx="12191695" cy="6858000" type="screen4x3"/>
   <p:notesSz cx="6858000" cy="9144000"/>
@@ -3312,7 +3316,7 @@
               </a:defRPr>
             </a:pPr>
             <a:r>
-              <a:t>ACCURACY: MODEL COMPARISON</a:t>
+              <a:t>EVALUATION: ACCURACY METRICS</a:t>
             </a:r>
           </a:p>
         </p:txBody>
@@ -3372,7 +3376,7 @@
               </a:defRPr>
             </a:pPr>
             <a:r>
-              <a:t>Precision@K, Recall@K, NDCG@K, MRR, Hit Rate across all 8 models.</a:t>
+              <a:t>Prediction metrics (MAE, RMSE) and ranking metrics (Precision@10, Recall@10, NDCG@10, MRR, Hit Rate@10) across all 8 models.</a:t>
             </a:r>
           </a:p>
         </p:txBody>
@@ -3434,7 +3438,7 @@
               </a:defRPr>
             </a:pPr>
             <a:r>
-              <a:t>BEYOND ACCURACY</a:t>
+              <a:t>EVALUATION: BEYOND ACCURACY</a:t>
             </a:r>
           </a:p>
         </p:txBody>
@@ -3494,7 +3498,7 @@
               </a:defRPr>
             </a:pPr>
             <a:r>
-              <a:t>Per-user metric distributions showing variance across users (Precision@K and NDCG@K).</a:t>
+              <a:t>Beyond-accuracy measures: Coverage, Diversity, Novelty, Popularity Bias, Serendipity, Fairness. Per-user distributions reveal high variance -- mean alone does not tell the full story.</a:t>
             </a:r>
           </a:p>
         </p:txBody>
@@ -3533,58 +3537,77 @@
         </p:nvSpPr>
         <p:spPr>
           <a:xfrm>
-            <a:off x="731520" y="365760"/>
-            <a:ext cx="10058400" cy="731520"/>
-          </a:xfrm>
-          <a:prstGeom prst="rect">
-            <a:avLst/>
-          </a:prstGeom>
-          <a:noFill/>
-        </p:spPr>
-        <p:txBody>
-          <a:bodyPr wrap="square">
-            <a:spAutoFit/>
-          </a:bodyPr>
-          <a:lstStyle/>
-          <a:p>
-            <a:pPr algn="l">
-              <a:defRPr sz="3200" b="1">
-                <a:solidFill>
-                  <a:srgbClr val="E5E5E5"/>
-                </a:solidFill>
-                <a:latin typeface="Calibri"/>
-              </a:defRPr>
-            </a:pPr>
-            <a:r>
-              <a:t>TRADE-OFF: PRECISION vs DIVERSITY vs NOVELTY</a:t>
-            </a:r>
-          </a:p>
-        </p:txBody>
-      </p:sp>
-      <p:pic>
-        <p:nvPicPr>
-          <p:cNvPr id="3" name="Picture 2" descr="tradeoff_analysis.png"/>
-          <p:cNvPicPr>
-            <a:picLocks noChangeAspect="1"/>
-          </p:cNvPicPr>
-          <p:nvPr/>
-        </p:nvPicPr>
-        <p:blipFill>
-          <a:blip r:embed="rId2"/>
-          <a:stretch>
-            <a:fillRect/>
-          </a:stretch>
-        </p:blipFill>
-        <p:spPr>
-          <a:xfrm>
-            <a:off x="731520" y="1371600"/>
-            <a:ext cx="10515600" cy="4846320"/>
-          </a:xfrm>
-          <a:prstGeom prst="rect">
-            <a:avLst/>
-          </a:prstGeom>
-        </p:spPr>
-      </p:pic>
+            <a:off x="731520" y="457200"/>
+            <a:ext cx="10058400" cy="914400"/>
+          </a:xfrm>
+          <a:prstGeom prst="rect">
+            <a:avLst/>
+          </a:prstGeom>
+          <a:noFill/>
+        </p:spPr>
+        <p:txBody>
+          <a:bodyPr wrap="square">
+            <a:spAutoFit/>
+          </a:bodyPr>
+          <a:lstStyle/>
+          <a:p>
+            <a:pPr algn="l">
+              <a:defRPr sz="3600" b="1">
+                <a:solidFill>
+                  <a:srgbClr val="E5E5E5"/>
+                </a:solidFill>
+                <a:latin typeface="Calibri"/>
+              </a:defRPr>
+            </a:pPr>
+            <a:r>
+              <a:t>METHOD COMPARISON: ALL MODELS, SAME DATA</a:t>
+            </a:r>
+          </a:p>
+        </p:txBody>
+      </p:sp>
+      <p:sp>
+        <p:nvSpPr>
+          <p:cNvPr id="3" name="Rectangle 2"/>
+          <p:cNvSpPr/>
+          <p:nvPr/>
+        </p:nvSpPr>
+        <p:spPr>
+          <a:xfrm>
+            <a:off x="731520" y="1188720"/>
+            <a:ext cx="1371600" cy="54864"/>
+          </a:xfrm>
+          <a:prstGeom prst="rect">
+            <a:avLst/>
+          </a:prstGeom>
+          <a:solidFill>
+            <a:srgbClr val="E8403E"/>
+          </a:solidFill>
+          <a:ln>
+            <a:noFill/>
+          </a:ln>
+        </p:spPr>
+        <p:style>
+          <a:lnRef idx="1">
+            <a:schemeClr val="accent1"/>
+          </a:lnRef>
+          <a:fillRef idx="3">
+            <a:schemeClr val="accent1"/>
+          </a:fillRef>
+          <a:effectRef idx="2">
+            <a:schemeClr val="accent1"/>
+          </a:effectRef>
+          <a:fontRef idx="minor">
+            <a:schemeClr val="lt1"/>
+          </a:fontRef>
+        </p:style>
+        <p:txBody>
+          <a:bodyPr rtlCol="0" anchor="ctr"/>
+          <a:lstStyle/>
+          <a:p>
+            <a:pPr algn="ctr"/>
+          </a:p>
+        </p:txBody>
+      </p:sp>
       <p:sp>
         <p:nvSpPr>
           <p:cNvPr id="4" name="TextBox 3"/>
@@ -3593,30 +3616,387 @@
         </p:nvSpPr>
         <p:spPr>
           <a:xfrm>
-            <a:off x="731520" y="6309360"/>
-            <a:ext cx="10058400" cy="457200"/>
-          </a:xfrm>
-          <a:prstGeom prst="rect">
-            <a:avLst/>
-          </a:prstGeom>
-          <a:noFill/>
-        </p:spPr>
-        <p:txBody>
-          <a:bodyPr wrap="square">
-            <a:spAutoFit/>
-          </a:bodyPr>
-          <a:lstStyle/>
-          <a:p>
-            <a:pPr algn="l">
-              <a:defRPr sz="1200" b="0">
-                <a:solidFill>
-                  <a:srgbClr val="808080"/>
-                </a:solidFill>
-                <a:latin typeface="Calibri"/>
-              </a:defRPr>
-            </a:pPr>
-            <a:r>
-              <a:t>Core trade-off from lectures: accuracy vs. diversity/novelty/coverage. No single model dominates all dimensions.</a:t>
+            <a:off x="914400" y="1645920"/>
+            <a:ext cx="9601200" cy="457200"/>
+          </a:xfrm>
+          <a:prstGeom prst="rect">
+            <a:avLst/>
+          </a:prstGeom>
+          <a:noFill/>
+        </p:spPr>
+        <p:txBody>
+          <a:bodyPr wrap="square">
+            <a:spAutoFit/>
+          </a:bodyPr>
+          <a:lstStyle/>
+          <a:p>
+            <a:pPr algn="l">
+              <a:defRPr sz="1600" b="0">
+                <a:solidFill>
+                  <a:srgbClr val="E5E5E5"/>
+                </a:solidFill>
+                <a:latin typeface="Calibri"/>
+              </a:defRPr>
+            </a:pPr>
+            <a:r>
+              <a:t>                         P@10     RMSE    Coverage  Novelty  Pop Bias   Time</a:t>
+            </a:r>
+          </a:p>
+        </p:txBody>
+      </p:sp>
+      <p:sp>
+        <p:nvSpPr>
+          <p:cNvPr id="5" name="TextBox 4"/>
+          <p:cNvSpPr txBox="1"/>
+          <p:nvPr/>
+        </p:nvSpPr>
+        <p:spPr>
+          <a:xfrm>
+            <a:off x="914400" y="2057400"/>
+            <a:ext cx="9601200" cy="457200"/>
+          </a:xfrm>
+          <a:prstGeom prst="rect">
+            <a:avLst/>
+          </a:prstGeom>
+          <a:noFill/>
+        </p:spPr>
+        <p:txBody>
+          <a:bodyPr wrap="square">
+            <a:spAutoFit/>
+          </a:bodyPr>
+          <a:lstStyle/>
+          <a:p>
+            <a:pPr algn="l">
+              <a:defRPr sz="1600" b="0">
+                <a:solidFill>
+                  <a:srgbClr val="E5E5E5"/>
+                </a:solidFill>
+                <a:latin typeface="Calibri"/>
+              </a:defRPr>
+            </a:pPr>
+            <a:r>
+              <a:t>  Most Popular           0.122     --       0.6%      1.7      100%    0.003s</a:t>
+            </a:r>
+          </a:p>
+        </p:txBody>
+      </p:sp>
+      <p:sp>
+        <p:nvSpPr>
+          <p:cNvPr id="6" name="TextBox 5"/>
+          <p:cNvSpPr txBox="1"/>
+          <p:nvPr/>
+        </p:nvSpPr>
+        <p:spPr>
+          <a:xfrm>
+            <a:off x="914400" y="2468880"/>
+            <a:ext cx="9601200" cy="457200"/>
+          </a:xfrm>
+          <a:prstGeom prst="rect">
+            <a:avLst/>
+          </a:prstGeom>
+          <a:noFill/>
+        </p:spPr>
+        <p:txBody>
+          <a:bodyPr wrap="square">
+            <a:spAutoFit/>
+          </a:bodyPr>
+          <a:lstStyle/>
+          <a:p>
+            <a:pPr algn="l">
+              <a:defRPr sz="1600" b="0">
+                <a:solidFill>
+                  <a:srgbClr val="E5E5E5"/>
+                </a:solidFill>
+                <a:latin typeface="Calibri"/>
+              </a:defRPr>
+            </a:pPr>
+            <a:r>
+              <a:t>  Highest Average        0.046     --       0.3%      3.4       88%    0.005s</a:t>
+            </a:r>
+          </a:p>
+        </p:txBody>
+      </p:sp>
+      <p:sp>
+        <p:nvSpPr>
+          <p:cNvPr id="7" name="TextBox 6"/>
+          <p:cNvSpPr txBox="1"/>
+          <p:nvPr/>
+        </p:nvSpPr>
+        <p:spPr>
+          <a:xfrm>
+            <a:off x="914400" y="2880360"/>
+            <a:ext cx="9601200" cy="457200"/>
+          </a:xfrm>
+          <a:prstGeom prst="rect">
+            <a:avLst/>
+          </a:prstGeom>
+          <a:noFill/>
+        </p:spPr>
+        <p:txBody>
+          <a:bodyPr wrap="square">
+            <a:spAutoFit/>
+          </a:bodyPr>
+          <a:lstStyle/>
+          <a:p>
+            <a:pPr algn="l">
+              <a:defRPr sz="1600" b="0">
+                <a:solidFill>
+                  <a:srgbClr val="E5E5E5"/>
+                </a:solidFill>
+                <a:latin typeface="Calibri"/>
+              </a:defRPr>
+            </a:pPr>
+            <a:r>
+              <a:t>  Content-Based          0.009     --      20.6%      6.8       19%    0.034s</a:t>
+            </a:r>
+          </a:p>
+        </p:txBody>
+      </p:sp>
+      <p:sp>
+        <p:nvSpPr>
+          <p:cNvPr id="8" name="TextBox 7"/>
+          <p:cNvSpPr txBox="1"/>
+          <p:nvPr/>
+        </p:nvSpPr>
+        <p:spPr>
+          <a:xfrm>
+            <a:off x="914400" y="3291840"/>
+            <a:ext cx="9601200" cy="457200"/>
+          </a:xfrm>
+          <a:prstGeom prst="rect">
+            <a:avLst/>
+          </a:prstGeom>
+          <a:noFill/>
+        </p:spPr>
+        <p:txBody>
+          <a:bodyPr wrap="square">
+            <a:spAutoFit/>
+          </a:bodyPr>
+          <a:lstStyle/>
+          <a:p>
+            <a:pPr algn="l">
+              <a:defRPr sz="1600" b="0">
+                <a:solidFill>
+                  <a:srgbClr val="E5E5E5"/>
+                </a:solidFill>
+                <a:latin typeface="Calibri"/>
+              </a:defRPr>
+            </a:pPr>
+            <a:r>
+              <a:t>  CB + Tags              0.008     --      21.2%      7.1       16%    0.322s</a:t>
+            </a:r>
+          </a:p>
+        </p:txBody>
+      </p:sp>
+      <p:sp>
+        <p:nvSpPr>
+          <p:cNvPr id="9" name="TextBox 8"/>
+          <p:cNvSpPr txBox="1"/>
+          <p:nvPr/>
+        </p:nvSpPr>
+        <p:spPr>
+          <a:xfrm>
+            <a:off x="914400" y="3703320"/>
+            <a:ext cx="9601200" cy="457200"/>
+          </a:xfrm>
+          <a:prstGeom prst="rect">
+            <a:avLst/>
+          </a:prstGeom>
+          <a:noFill/>
+        </p:spPr>
+        <p:txBody>
+          <a:bodyPr wrap="square">
+            <a:spAutoFit/>
+          </a:bodyPr>
+          <a:lstStyle/>
+          <a:p>
+            <a:pPr algn="l">
+              <a:defRPr sz="1600" b="0">
+                <a:solidFill>
+                  <a:srgbClr val="E5E5E5"/>
+                </a:solidFill>
+                <a:latin typeface="Calibri"/>
+              </a:defRPr>
+            </a:pPr>
+            <a:r>
+              <a:t>  User-User CF           0.000    0.893     2.1%      9.1        0%   12.35s</a:t>
+            </a:r>
+          </a:p>
+        </p:txBody>
+      </p:sp>
+      <p:sp>
+        <p:nvSpPr>
+          <p:cNvPr id="10" name="TextBox 9"/>
+          <p:cNvSpPr txBox="1"/>
+          <p:nvPr/>
+        </p:nvSpPr>
+        <p:spPr>
+          <a:xfrm>
+            <a:off x="914400" y="4114800"/>
+            <a:ext cx="9601200" cy="457200"/>
+          </a:xfrm>
+          <a:prstGeom prst="rect">
+            <a:avLst/>
+          </a:prstGeom>
+          <a:noFill/>
+        </p:spPr>
+        <p:txBody>
+          <a:bodyPr wrap="square">
+            <a:spAutoFit/>
+          </a:bodyPr>
+          <a:lstStyle/>
+          <a:p>
+            <a:pPr algn="l">
+              <a:defRPr sz="1600" b="0">
+                <a:solidFill>
+                  <a:srgbClr val="E5E5E5"/>
+                </a:solidFill>
+                <a:latin typeface="Calibri"/>
+              </a:defRPr>
+            </a:pPr>
+            <a:r>
+              <a:t>  Item-Item CF           0.000    0.935     5.0%      9.2        0%    3.84s</a:t>
+            </a:r>
+          </a:p>
+        </p:txBody>
+      </p:sp>
+      <p:sp>
+        <p:nvSpPr>
+          <p:cNvPr id="11" name="TextBox 10"/>
+          <p:cNvSpPr txBox="1"/>
+          <p:nvPr/>
+        </p:nvSpPr>
+        <p:spPr>
+          <a:xfrm>
+            <a:off x="914400" y="4526280"/>
+            <a:ext cx="9601200" cy="457200"/>
+          </a:xfrm>
+          <a:prstGeom prst="rect">
+            <a:avLst/>
+          </a:prstGeom>
+          <a:noFill/>
+        </p:spPr>
+        <p:txBody>
+          <a:bodyPr wrap="square">
+            <a:spAutoFit/>
+          </a:bodyPr>
+          <a:lstStyle/>
+          <a:p>
+            <a:pPr algn="l">
+              <a:defRPr sz="1600" b="0">
+                <a:solidFill>
+                  <a:srgbClr val="E5E5E5"/>
+                </a:solidFill>
+                <a:latin typeface="Calibri"/>
+              </a:defRPr>
+            </a:pPr>
+            <a:r>
+              <a:t>  Matrix Factorization   0.053    0.881     2.4%      3.3       86%   19.87s</a:t>
+            </a:r>
+          </a:p>
+        </p:txBody>
+      </p:sp>
+      <p:sp>
+        <p:nvSpPr>
+          <p:cNvPr id="12" name="TextBox 11"/>
+          <p:cNvSpPr txBox="1"/>
+          <p:nvPr/>
+        </p:nvSpPr>
+        <p:spPr>
+          <a:xfrm>
+            <a:off x="914400" y="4937760"/>
+            <a:ext cx="9601200" cy="457200"/>
+          </a:xfrm>
+          <a:prstGeom prst="rect">
+            <a:avLst/>
+          </a:prstGeom>
+          <a:noFill/>
+        </p:spPr>
+        <p:txBody>
+          <a:bodyPr wrap="square">
+            <a:spAutoFit/>
+          </a:bodyPr>
+          <a:lstStyle/>
+          <a:p>
+            <a:pPr algn="l">
+              <a:defRPr sz="1600" b="0">
+                <a:solidFill>
+                  <a:srgbClr val="E5E5E5"/>
+                </a:solidFill>
+                <a:latin typeface="Calibri"/>
+              </a:defRPr>
+            </a:pPr>
+          </a:p>
+        </p:txBody>
+      </p:sp>
+      <p:sp>
+        <p:nvSpPr>
+          <p:cNvPr id="13" name="TextBox 12"/>
+          <p:cNvSpPr txBox="1"/>
+          <p:nvPr/>
+        </p:nvSpPr>
+        <p:spPr>
+          <a:xfrm>
+            <a:off x="914400" y="5349240"/>
+            <a:ext cx="9601200" cy="457200"/>
+          </a:xfrm>
+          <a:prstGeom prst="rect">
+            <a:avLst/>
+          </a:prstGeom>
+          <a:noFill/>
+        </p:spPr>
+        <p:txBody>
+          <a:bodyPr wrap="square">
+            <a:spAutoFit/>
+          </a:bodyPr>
+          <a:lstStyle/>
+          <a:p>
+            <a:pPr algn="l">
+              <a:defRPr sz="1600" b="0">
+                <a:solidFill>
+                  <a:srgbClr val="E5E5E5"/>
+                </a:solidFill>
+                <a:latin typeface="Calibri"/>
+              </a:defRPr>
+            </a:pPr>
+            <a:r>
+              <a:t>Ranking metrics | Prediction metrics | Beyond-accuracy measures -- all three categories shown.</a:t>
+            </a:r>
+          </a:p>
+        </p:txBody>
+      </p:sp>
+      <p:sp>
+        <p:nvSpPr>
+          <p:cNvPr id="14" name="TextBox 13"/>
+          <p:cNvSpPr txBox="1"/>
+          <p:nvPr/>
+        </p:nvSpPr>
+        <p:spPr>
+          <a:xfrm>
+            <a:off x="914400" y="5760720"/>
+            <a:ext cx="9601200" cy="457200"/>
+          </a:xfrm>
+          <a:prstGeom prst="rect">
+            <a:avLst/>
+          </a:prstGeom>
+          <a:noFill/>
+        </p:spPr>
+        <p:txBody>
+          <a:bodyPr wrap="square">
+            <a:spAutoFit/>
+          </a:bodyPr>
+          <a:lstStyle/>
+          <a:p>
+            <a:pPr algn="l">
+              <a:defRPr sz="1600" b="0">
+                <a:solidFill>
+                  <a:srgbClr val="E5E5E5"/>
+                </a:solidFill>
+                <a:latin typeface="Calibri"/>
+              </a:defRPr>
+            </a:pPr>
+            <a:r>
+              <a:t>No single model dominates all dimensions: this IS the core lecture insight.</a:t>
             </a:r>
           </a:p>
         </p:txBody>
@@ -3678,14 +4058,14 @@
               </a:defRPr>
             </a:pPr>
             <a:r>
-              <a:t>MULTI-DIMENSIONAL MODEL COMPARISON</a:t>
+              <a:t>TRADE-OFF: PRECISION vs DIVERSITY vs NOVELTY</a:t>
             </a:r>
           </a:p>
         </p:txBody>
       </p:sp>
       <p:pic>
         <p:nvPicPr>
-          <p:cNvPr id="3" name="Picture 2" descr="radar_chart.png"/>
+          <p:cNvPr id="3" name="Picture 2" descr="tradeoff_analysis.png"/>
           <p:cNvPicPr>
             <a:picLocks noChangeAspect="1"/>
           </p:cNvPicPr>
@@ -3738,7 +4118,7 @@
               </a:defRPr>
             </a:pPr>
             <a:r>
-              <a:t>Normalized radar chart: each model excels in different dimensions. Hybrid approaches are needed.</a:t>
+              <a:t>Example: Most Popular has 13x higher Precision than Content-Based (0.122 vs 0.009) but 34x lower Coverage (0.6% vs 20.6%) and 4x higher Popularity Bias (100% vs 19%). As the lectures emphasise: accuracy is not enough.</a:t>
             </a:r>
           </a:p>
         </p:txBody>
@@ -3777,77 +4157,58 @@
         </p:nvSpPr>
         <p:spPr>
           <a:xfrm>
-            <a:off x="731520" y="457200"/>
-            <a:ext cx="10058400" cy="914400"/>
-          </a:xfrm>
-          <a:prstGeom prst="rect">
-            <a:avLst/>
-          </a:prstGeom>
-          <a:noFill/>
-        </p:spPr>
-        <p:txBody>
-          <a:bodyPr wrap="square">
-            <a:spAutoFit/>
-          </a:bodyPr>
-          <a:lstStyle/>
-          <a:p>
-            <a:pPr algn="l">
-              <a:defRPr sz="3600" b="1">
-                <a:solidFill>
-                  <a:srgbClr val="E5E5E5"/>
-                </a:solidFill>
-                <a:latin typeface="Calibri"/>
-              </a:defRPr>
-            </a:pPr>
-            <a:r>
-              <a:t>FAIRNESS &amp; POPULARITY BIAS</a:t>
-            </a:r>
-          </a:p>
-        </p:txBody>
-      </p:sp>
-      <p:sp>
-        <p:nvSpPr>
-          <p:cNvPr id="3" name="Rectangle 2"/>
-          <p:cNvSpPr/>
-          <p:nvPr/>
-        </p:nvSpPr>
-        <p:spPr>
-          <a:xfrm>
-            <a:off x="731520" y="1188720"/>
-            <a:ext cx="1371600" cy="54864"/>
-          </a:xfrm>
-          <a:prstGeom prst="rect">
-            <a:avLst/>
-          </a:prstGeom>
-          <a:solidFill>
-            <a:srgbClr val="E8403E"/>
-          </a:solidFill>
-          <a:ln>
-            <a:noFill/>
-          </a:ln>
-        </p:spPr>
-        <p:style>
-          <a:lnRef idx="1">
-            <a:schemeClr val="accent1"/>
-          </a:lnRef>
-          <a:fillRef idx="3">
-            <a:schemeClr val="accent1"/>
-          </a:fillRef>
-          <a:effectRef idx="2">
-            <a:schemeClr val="accent1"/>
-          </a:effectRef>
-          <a:fontRef idx="minor">
-            <a:schemeClr val="lt1"/>
-          </a:fontRef>
-        </p:style>
-        <p:txBody>
-          <a:bodyPr rtlCol="0" anchor="ctr"/>
-          <a:lstStyle/>
-          <a:p>
-            <a:pPr algn="ctr"/>
-          </a:p>
-        </p:txBody>
-      </p:sp>
+            <a:off x="731520" y="365760"/>
+            <a:ext cx="10058400" cy="731520"/>
+          </a:xfrm>
+          <a:prstGeom prst="rect">
+            <a:avLst/>
+          </a:prstGeom>
+          <a:noFill/>
+        </p:spPr>
+        <p:txBody>
+          <a:bodyPr wrap="square">
+            <a:spAutoFit/>
+          </a:bodyPr>
+          <a:lstStyle/>
+          <a:p>
+            <a:pPr algn="l">
+              <a:defRPr sz="3200" b="1">
+                <a:solidFill>
+                  <a:srgbClr val="E5E5E5"/>
+                </a:solidFill>
+                <a:latin typeface="Calibri"/>
+              </a:defRPr>
+            </a:pPr>
+            <a:r>
+              <a:t>MULTI-DIMENSIONAL MODEL COMPARISON</a:t>
+            </a:r>
+          </a:p>
+        </p:txBody>
+      </p:sp>
+      <p:pic>
+        <p:nvPicPr>
+          <p:cNvPr id="3" name="Picture 2" descr="radar_chart.png"/>
+          <p:cNvPicPr>
+            <a:picLocks noChangeAspect="1"/>
+          </p:cNvPicPr>
+          <p:nvPr/>
+        </p:nvPicPr>
+        <p:blipFill>
+          <a:blip r:embed="rId2"/>
+          <a:stretch>
+            <a:fillRect/>
+          </a:stretch>
+        </p:blipFill>
+        <p:spPr>
+          <a:xfrm>
+            <a:off x="731520" y="1371600"/>
+            <a:ext cx="10515600" cy="4846320"/>
+          </a:xfrm>
+          <a:prstGeom prst="rect">
+            <a:avLst/>
+          </a:prstGeom>
+        </p:spPr>
+      </p:pic>
       <p:sp>
         <p:nvSpPr>
           <p:cNvPr id="4" name="TextBox 3"/>
@@ -3856,348 +4217,30 @@
         </p:nvSpPr>
         <p:spPr>
           <a:xfrm>
-            <a:off x="914400" y="1645920"/>
-            <a:ext cx="9601200" cy="457200"/>
-          </a:xfrm>
-          <a:prstGeom prst="rect">
-            <a:avLst/>
-          </a:prstGeom>
-          <a:noFill/>
-        </p:spPr>
-        <p:txBody>
-          <a:bodyPr wrap="square">
-            <a:spAutoFit/>
-          </a:bodyPr>
-          <a:lstStyle/>
-          <a:p>
-            <a:pPr algn="l">
-              <a:defRPr sz="1600" b="0">
-                <a:solidFill>
-                  <a:srgbClr val="E5E5E5"/>
-                </a:solidFill>
-                <a:latin typeface="Calibri"/>
-              </a:defRPr>
-            </a:pPr>
-            <a:r>
-              <a:t>Fairness: NDCG@K gap between heavy raters (&gt;50th percentile) and light raters</a:t>
-            </a:r>
-          </a:p>
-        </p:txBody>
-      </p:sp>
-      <p:sp>
-        <p:nvSpPr>
-          <p:cNvPr id="5" name="TextBox 4"/>
-          <p:cNvSpPr txBox="1"/>
-          <p:nvPr/>
-        </p:nvSpPr>
-        <p:spPr>
-          <a:xfrm>
-            <a:off x="914400" y="2057400"/>
-            <a:ext cx="9601200" cy="457200"/>
-          </a:xfrm>
-          <a:prstGeom prst="rect">
-            <a:avLst/>
-          </a:prstGeom>
-          <a:noFill/>
-        </p:spPr>
-        <p:txBody>
-          <a:bodyPr wrap="square">
-            <a:spAutoFit/>
-          </a:bodyPr>
-          <a:lstStyle/>
-          <a:p>
-            <a:pPr algn="l">
-              <a:defRPr sz="1600" b="0">
-                <a:solidFill>
-                  <a:srgbClr val="E5E5E5"/>
-                </a:solidFill>
-                <a:latin typeface="Calibri"/>
-              </a:defRPr>
-            </a:pPr>
-          </a:p>
-        </p:txBody>
-      </p:sp>
-      <p:sp>
-        <p:nvSpPr>
-          <p:cNvPr id="6" name="TextBox 5"/>
-          <p:cNvSpPr txBox="1"/>
-          <p:nvPr/>
-        </p:nvSpPr>
-        <p:spPr>
-          <a:xfrm>
-            <a:off x="914400" y="2468880"/>
-            <a:ext cx="9601200" cy="457200"/>
-          </a:xfrm>
-          <a:prstGeom prst="rect">
-            <a:avLst/>
-          </a:prstGeom>
-          <a:noFill/>
-        </p:spPr>
-        <p:txBody>
-          <a:bodyPr wrap="square">
-            <a:spAutoFit/>
-          </a:bodyPr>
-          <a:lstStyle/>
-          <a:p>
-            <a:pPr algn="l">
-              <a:defRPr sz="1600" b="0">
-                <a:solidFill>
-                  <a:srgbClr val="E5E5E5"/>
-                </a:solidFill>
-                <a:latin typeface="Calibri"/>
-              </a:defRPr>
-            </a:pPr>
-            <a:r>
-              <a:t>Largest gap: Most Popular (0.156) -- heavy raters benefit disproportionately</a:t>
-            </a:r>
-          </a:p>
-        </p:txBody>
-      </p:sp>
-      <p:sp>
-        <p:nvSpPr>
-          <p:cNvPr id="7" name="TextBox 6"/>
-          <p:cNvSpPr txBox="1"/>
-          <p:nvPr/>
-        </p:nvSpPr>
-        <p:spPr>
-          <a:xfrm>
-            <a:off x="914400" y="2880360"/>
-            <a:ext cx="9601200" cy="457200"/>
-          </a:xfrm>
-          <a:prstGeom prst="rect">
-            <a:avLst/>
-          </a:prstGeom>
-          <a:noFill/>
-        </p:spPr>
-        <p:txBody>
-          <a:bodyPr wrap="square">
-            <a:spAutoFit/>
-          </a:bodyPr>
-          <a:lstStyle/>
-          <a:p>
-            <a:pPr algn="l">
-              <a:defRPr sz="1600" b="0">
-                <a:solidFill>
-                  <a:srgbClr val="E5E5E5"/>
-                </a:solidFill>
-                <a:latin typeface="Calibri"/>
-              </a:defRPr>
-            </a:pPr>
-            <a:r>
-              <a:t>Matrix Factorization gap: 0.143 -- also biased toward active users</a:t>
-            </a:r>
-          </a:p>
-        </p:txBody>
-      </p:sp>
-      <p:sp>
-        <p:nvSpPr>
-          <p:cNvPr id="8" name="TextBox 7"/>
-          <p:cNvSpPr txBox="1"/>
-          <p:nvPr/>
-        </p:nvSpPr>
-        <p:spPr>
-          <a:xfrm>
-            <a:off x="914400" y="3291840"/>
-            <a:ext cx="9601200" cy="457200"/>
-          </a:xfrm>
-          <a:prstGeom prst="rect">
-            <a:avLst/>
-          </a:prstGeom>
-          <a:noFill/>
-        </p:spPr>
-        <p:txBody>
-          <a:bodyPr wrap="square">
-            <a:spAutoFit/>
-          </a:bodyPr>
-          <a:lstStyle/>
-          <a:p>
-            <a:pPr algn="l">
-              <a:defRPr sz="1600" b="0">
-                <a:solidFill>
-                  <a:srgbClr val="E5E5E5"/>
-                </a:solidFill>
-                <a:latin typeface="Calibri"/>
-              </a:defRPr>
-            </a:pPr>
-            <a:r>
-              <a:t>CB+Tags gap: 0.005 -- most equitable across user groups</a:t>
-            </a:r>
-          </a:p>
-        </p:txBody>
-      </p:sp>
-      <p:sp>
-        <p:nvSpPr>
-          <p:cNvPr id="9" name="TextBox 8"/>
-          <p:cNvSpPr txBox="1"/>
-          <p:nvPr/>
-        </p:nvSpPr>
-        <p:spPr>
-          <a:xfrm>
-            <a:off x="914400" y="3703320"/>
-            <a:ext cx="9601200" cy="457200"/>
-          </a:xfrm>
-          <a:prstGeom prst="rect">
-            <a:avLst/>
-          </a:prstGeom>
-          <a:noFill/>
-        </p:spPr>
-        <p:txBody>
-          <a:bodyPr wrap="square">
-            <a:spAutoFit/>
-          </a:bodyPr>
-          <a:lstStyle/>
-          <a:p>
-            <a:pPr algn="l">
-              <a:defRPr sz="1600" b="0">
-                <a:solidFill>
-                  <a:srgbClr val="E5E5E5"/>
-                </a:solidFill>
-                <a:latin typeface="Calibri"/>
-              </a:defRPr>
-            </a:pPr>
-            <a:r>
-              <a:t>Random gap: 0.003 -- naturally fair (no personalization)</a:t>
-            </a:r>
-          </a:p>
-        </p:txBody>
-      </p:sp>
-      <p:sp>
-        <p:nvSpPr>
-          <p:cNvPr id="10" name="TextBox 9"/>
-          <p:cNvSpPr txBox="1"/>
-          <p:nvPr/>
-        </p:nvSpPr>
-        <p:spPr>
-          <a:xfrm>
-            <a:off x="914400" y="4114800"/>
-            <a:ext cx="9601200" cy="457200"/>
-          </a:xfrm>
-          <a:prstGeom prst="rect">
-            <a:avLst/>
-          </a:prstGeom>
-          <a:noFill/>
-        </p:spPr>
-        <p:txBody>
-          <a:bodyPr wrap="square">
-            <a:spAutoFit/>
-          </a:bodyPr>
-          <a:lstStyle/>
-          <a:p>
-            <a:pPr algn="l">
-              <a:defRPr sz="1600" b="0">
-                <a:solidFill>
-                  <a:srgbClr val="E5E5E5"/>
-                </a:solidFill>
-                <a:latin typeface="Calibri"/>
-              </a:defRPr>
-            </a:pPr>
-          </a:p>
-        </p:txBody>
-      </p:sp>
-      <p:sp>
-        <p:nvSpPr>
-          <p:cNvPr id="11" name="TextBox 10"/>
-          <p:cNvSpPr txBox="1"/>
-          <p:nvPr/>
-        </p:nvSpPr>
-        <p:spPr>
-          <a:xfrm>
-            <a:off x="914400" y="4526280"/>
-            <a:ext cx="9601200" cy="457200"/>
-          </a:xfrm>
-          <a:prstGeom prst="rect">
-            <a:avLst/>
-          </a:prstGeom>
-          <a:noFill/>
-        </p:spPr>
-        <p:txBody>
-          <a:bodyPr wrap="square">
-            <a:spAutoFit/>
-          </a:bodyPr>
-          <a:lstStyle/>
-          <a:p>
-            <a:pPr algn="l">
-              <a:defRPr sz="1600" b="0">
-                <a:solidFill>
-                  <a:srgbClr val="E5E5E5"/>
-                </a:solidFill>
-                <a:latin typeface="Calibri"/>
-              </a:defRPr>
-            </a:pPr>
-            <a:r>
-              <a:t>Popularity bias: Most Popular = 100% from top 10% items</a:t>
-            </a:r>
-          </a:p>
-        </p:txBody>
-      </p:sp>
-      <p:sp>
-        <p:nvSpPr>
-          <p:cNvPr id="12" name="TextBox 11"/>
-          <p:cNvSpPr txBox="1"/>
-          <p:nvPr/>
-        </p:nvSpPr>
-        <p:spPr>
-          <a:xfrm>
-            <a:off x="914400" y="4937760"/>
-            <a:ext cx="9601200" cy="457200"/>
-          </a:xfrm>
-          <a:prstGeom prst="rect">
-            <a:avLst/>
-          </a:prstGeom>
-          <a:noFill/>
-        </p:spPr>
-        <p:txBody>
-          <a:bodyPr wrap="square">
-            <a:spAutoFit/>
-          </a:bodyPr>
-          <a:lstStyle/>
-          <a:p>
-            <a:pPr algn="l">
-              <a:defRPr sz="1600" b="0">
-                <a:solidFill>
-                  <a:srgbClr val="E5E5E5"/>
-                </a:solidFill>
-                <a:latin typeface="Calibri"/>
-              </a:defRPr>
-            </a:pPr>
-            <a:r>
-              <a:t>CF methods = 0% popularity bias (but also near-zero precision)</a:t>
-            </a:r>
-          </a:p>
-        </p:txBody>
-      </p:sp>
-      <p:sp>
-        <p:nvSpPr>
-          <p:cNvPr id="13" name="TextBox 12"/>
-          <p:cNvSpPr txBox="1"/>
-          <p:nvPr/>
-        </p:nvSpPr>
-        <p:spPr>
-          <a:xfrm>
-            <a:off x="914400" y="5349240"/>
-            <a:ext cx="9601200" cy="457200"/>
-          </a:xfrm>
-          <a:prstGeom prst="rect">
-            <a:avLst/>
-          </a:prstGeom>
-          <a:noFill/>
-        </p:spPr>
-        <p:txBody>
-          <a:bodyPr wrap="square">
-            <a:spAutoFit/>
-          </a:bodyPr>
-          <a:lstStyle/>
-          <a:p>
-            <a:pPr algn="l">
-              <a:defRPr sz="1600" b="0">
-                <a:solidFill>
-                  <a:srgbClr val="E5E5E5"/>
-                </a:solidFill>
-                <a:latin typeface="Calibri"/>
-              </a:defRPr>
-            </a:pPr>
-            <a:r>
-              <a:t>Production systems need explicit debiasing strategies</a:t>
+            <a:off x="731520" y="6309360"/>
+            <a:ext cx="10058400" cy="457200"/>
+          </a:xfrm>
+          <a:prstGeom prst="rect">
+            <a:avLst/>
+          </a:prstGeom>
+          <a:noFill/>
+        </p:spPr>
+        <p:txBody>
+          <a:bodyPr wrap="square">
+            <a:spAutoFit/>
+          </a:bodyPr>
+          <a:lstStyle/>
+          <a:p>
+            <a:pPr algn="l">
+              <a:defRPr sz="1200" b="0">
+                <a:solidFill>
+                  <a:srgbClr val="808080"/>
+                </a:solidFill>
+                <a:latin typeface="Calibri"/>
+              </a:defRPr>
+            </a:pPr>
+            <a:r>
+              <a:t>Normalized radar chart: each model excels in different dimensions. Diversity, novelty, bias, and scalability vary as much as accuracy.</a:t>
             </a:r>
           </a:p>
         </p:txBody>
@@ -4259,7 +4302,7 @@
               </a:defRPr>
             </a:pPr>
             <a:r>
-              <a:t>UX &amp; PROTOTYPE</a:t>
+              <a:t>FAIRNESS &amp; POPULARITY BIAS</a:t>
             </a:r>
           </a:p>
         </p:txBody>
@@ -4338,7 +4381,7 @@
               </a:defRPr>
             </a:pPr>
             <a:r>
-              <a:t>Netflix-inspired Streamlit UI with 6 pages</a:t>
+              <a:t>Fairness: NDCG@K gap between heavy raters (&gt;50th percentile) and light raters</a:t>
             </a:r>
           </a:p>
         </p:txBody>
@@ -4373,9 +4416,6 @@
                 <a:latin typeface="Calibri"/>
               </a:defRPr>
             </a:pPr>
-            <a:r>
-              <a:t>Design: dark theme (#141414), Bebas Neue / Inter / JetBrains Mono</a:t>
-            </a:r>
           </a:p>
         </p:txBody>
       </p:sp>
@@ -4410,7 +4450,7 @@
               </a:defRPr>
             </a:pPr>
             <a:r>
-              <a:t>Poster lazy loading via TMDb API with JSON cache</a:t>
+              <a:t>Largest gap: Most Popular (0.156) -- heavy raters benefit disproportionately</a:t>
             </a:r>
           </a:p>
         </p:txBody>
@@ -4445,6 +4485,9 @@
                 <a:latin typeface="Calibri"/>
               </a:defRPr>
             </a:pPr>
+            <a:r>
+              <a:t>Matrix Factorization gap: 0.143 -- also biased toward active users</a:t>
+            </a:r>
           </a:p>
         </p:txBody>
       </p:sp>
@@ -4479,7 +4522,7 @@
               </a:defRPr>
             </a:pPr>
             <a:r>
-              <a:t>Pages: Home (hero + trending), Discover (search + filter + similar),</a:t>
+              <a:t>CB+Tags gap: 0.005 -- most equitable across user groups</a:t>
             </a:r>
           </a:p>
         </p:txBody>
@@ -4515,7 +4558,7 @@
               </a:defRPr>
             </a:pPr>
             <a:r>
-              <a:t>  Recommendations (7 algorithms), User Profile (stats + genre radar),</a:t>
+              <a:t>Random gap: 0.003 -- naturally fair (no personalization)</a:t>
             </a:r>
           </a:p>
         </p:txBody>
@@ -4550,9 +4593,6 @@
                 <a:latin typeface="Calibri"/>
               </a:defRPr>
             </a:pPr>
-            <a:r>
-              <a:t>  Compare (side-by-side with overlap heatmap), Evaluation (full metrics)</a:t>
-            </a:r>
           </a:p>
         </p:txBody>
       </p:sp>
@@ -4586,6 +4626,9 @@
                 <a:latin typeface="Calibri"/>
               </a:defRPr>
             </a:pPr>
+            <a:r>
+              <a:t>Popularity bias: Most Popular = 100% from top 10% items</a:t>
+            </a:r>
           </a:p>
         </p:txBody>
       </p:sp>
@@ -4620,7 +4663,7 @@
               </a:defRPr>
             </a:pPr>
             <a:r>
-              <a:t>Poster cards with hover overlay showing title, year, genres, and 'why'</a:t>
+              <a:t>CF methods = 0% popularity bias (but also near-zero precision)</a:t>
             </a:r>
           </a:p>
         </p:txBody>
@@ -4656,7 +4699,7 @@
               </a:defRPr>
             </a:pPr>
             <a:r>
-              <a:t>Horizontal scroll rows mimicking Netflix filmstrip UX</a:t>
+              <a:t>Production systems need explicit debiasing strategies</a:t>
             </a:r>
           </a:p>
         </p:txBody>
@@ -4718,7 +4761,7 @@
               </a:defRPr>
             </a:pPr>
             <a:r>
-              <a:t>CONCLUSIONS &amp; LESSONS LEARNED</a:t>
+              <a:t>TECHNICAL CHALLENGES &amp; LIMITATIONS</a:t>
             </a:r>
           </a:p>
         </p:txBody>
@@ -4797,7 +4840,7 @@
               </a:defRPr>
             </a:pPr>
             <a:r>
-              <a:t>1. All formulas implemented exactly as in lecture slides (verified audit)</a:t>
+              <a:t>Sparsity (98.3%): the dominant challenge -- User-User CF finds too few</a:t>
             </a:r>
           </a:p>
         </p:txBody>
@@ -4833,7 +4876,7 @@
               </a:defRPr>
             </a:pPr>
             <a:r>
-              <a:t>2. Most Popular is surprisingly strong in sparse data (Precision@10 = 0.122)</a:t>
+              <a:t>  co-rated items for reliable Pearson correlations, P@10 drops to ~0</a:t>
             </a:r>
           </a:p>
         </p:txBody>
@@ -4868,9 +4911,6 @@
                 <a:latin typeface="Calibri"/>
               </a:defRPr>
             </a:pPr>
-            <a:r>
-              <a:t>3. CF struggles at 98.3% sparsity -- good discussion material</a:t>
-            </a:r>
           </a:p>
         </p:txBody>
       </p:sp>
@@ -4905,7 +4945,7 @@
               </a:defRPr>
             </a:pPr>
             <a:r>
-              <a:t>4. MF is the best personalized method (Precision = 0.053, RMSE = 0.881)</a:t>
+              <a:t>Cold-start: new users without history receive non-personalized fallback;</a:t>
             </a:r>
           </a:p>
         </p:txBody>
@@ -4941,7 +4981,7 @@
               </a:defRPr>
             </a:pPr>
             <a:r>
-              <a:t>5. Core trade-off: accuracy vs discovery (as lectures emphasize)</a:t>
+              <a:t>  new items without ratings are invisible to CF/MF (content-based can help)</a:t>
             </a:r>
           </a:p>
         </p:txBody>
@@ -4976,9 +5016,6 @@
                 <a:latin typeface="Calibri"/>
               </a:defRPr>
             </a:pPr>
-            <a:r>
-              <a:t>6. No single model dominates all dimensions</a:t>
-            </a:r>
           </a:p>
         </p:txBody>
       </p:sp>
@@ -5012,6 +5049,9 @@
                 <a:latin typeface="Calibri"/>
               </a:defRPr>
             </a:pPr>
+            <a:r>
+              <a:t>Scalability: User-User CF = O(n_users^2 * n_items), 12.3s to train;</a:t>
+            </a:r>
           </a:p>
         </p:txBody>
       </p:sp>
@@ -5046,7 +5086,7 @@
               </a:defRPr>
             </a:pPr>
             <a:r>
-              <a:t>Key insight from Netflix Prize (Folie 22):</a:t>
+              <a:t>  Most Popular = O(n_ratings), 0.003s -- 4000x faster for higher accuracy</a:t>
             </a:r>
           </a:p>
         </p:txBody>
@@ -5081,9 +5121,6 @@
                 <a:latin typeface="Calibri"/>
               </a:defRPr>
             </a:pPr>
-            <a:r>
-              <a:t>  'Ensembles win benchmarks' and 'Evaluation defines success'</a:t>
-            </a:r>
           </a:p>
         </p:txBody>
       </p:sp>
@@ -5118,7 +5155,1558 @@
               </a:defRPr>
             </a:pPr>
             <a:r>
-              <a:t>  RMSE alone does not capture recommendation quality</a:t>
+              <a:t>Popularity bias: Most Popular recommends only the top 0.6% of items,</a:t>
+            </a:r>
+          </a:p>
+        </p:txBody>
+      </p:sp>
+      <p:sp>
+        <p:nvSpPr>
+          <p:cNvPr id="14" name="TextBox 13"/>
+          <p:cNvSpPr txBox="1"/>
+          <p:nvPr/>
+        </p:nvSpPr>
+        <p:spPr>
+          <a:xfrm>
+            <a:off x="914400" y="5760720"/>
+            <a:ext cx="9601200" cy="457200"/>
+          </a:xfrm>
+          <a:prstGeom prst="rect">
+            <a:avLst/>
+          </a:prstGeom>
+          <a:noFill/>
+        </p:spPr>
+        <p:txBody>
+          <a:bodyPr wrap="square">
+            <a:spAutoFit/>
+          </a:bodyPr>
+          <a:lstStyle/>
+          <a:p>
+            <a:pPr algn="l">
+              <a:defRPr sz="1600" b="0">
+                <a:solidFill>
+                  <a:srgbClr val="E5E5E5"/>
+                </a:solidFill>
+                <a:latin typeface="Calibri"/>
+              </a:defRPr>
+            </a:pPr>
+            <a:r>
+              <a:t>  creating a rich-get-richer feedback loop in production systems</a:t>
+            </a:r>
+          </a:p>
+        </p:txBody>
+      </p:sp>
+    </p:spTree>
+  </p:cSld>
+  <p:clrMapOvr>
+    <a:masterClrMapping/>
+  </p:clrMapOvr>
+</p:sld>
+</file>
+
+<file path=ppt/slides/slide17.xml><?xml version="1.0" encoding="utf-8"?>
+<p:sld xmlns:a="http://schemas.openxmlformats.org/drawingml/2006/main" xmlns:p="http://schemas.openxmlformats.org/presentationml/2006/main" xmlns:r="http://schemas.openxmlformats.org/officeDocument/2006/relationships">
+  <p:cSld>
+    <p:bg>
+      <p:bgPr>
+        <a:solidFill>
+          <a:srgbClr val="141414"/>
+        </a:solidFill>
+        <a:effectLst/>
+      </p:bgPr>
+    </p:bg>
+    <p:spTree>
+      <p:nvGrpSpPr>
+        <p:cNvPr id="1" name=""/>
+        <p:cNvGrpSpPr/>
+        <p:nvPr/>
+      </p:nvGrpSpPr>
+      <p:grpSpPr/>
+      <p:sp>
+        <p:nvSpPr>
+          <p:cNvPr id="2" name="TextBox 1"/>
+          <p:cNvSpPr txBox="1"/>
+          <p:nvPr/>
+        </p:nvSpPr>
+        <p:spPr>
+          <a:xfrm>
+            <a:off x="731520" y="457200"/>
+            <a:ext cx="10058400" cy="914400"/>
+          </a:xfrm>
+          <a:prstGeom prst="rect">
+            <a:avLst/>
+          </a:prstGeom>
+          <a:noFill/>
+        </p:spPr>
+        <p:txBody>
+          <a:bodyPr wrap="square">
+            <a:spAutoFit/>
+          </a:bodyPr>
+          <a:lstStyle/>
+          <a:p>
+            <a:pPr algn="l">
+              <a:defRPr sz="3600" b="1">
+                <a:solidFill>
+                  <a:srgbClr val="E5E5E5"/>
+                </a:solidFill>
+                <a:latin typeface="Calibri"/>
+              </a:defRPr>
+            </a:pPr>
+            <a:r>
+              <a:t>ETHICAL &amp; SOCIAL IMPLICATIONS</a:t>
+            </a:r>
+          </a:p>
+        </p:txBody>
+      </p:sp>
+      <p:sp>
+        <p:nvSpPr>
+          <p:cNvPr id="3" name="Rectangle 2"/>
+          <p:cNvSpPr/>
+          <p:nvPr/>
+        </p:nvSpPr>
+        <p:spPr>
+          <a:xfrm>
+            <a:off x="731520" y="1188720"/>
+            <a:ext cx="1371600" cy="54864"/>
+          </a:xfrm>
+          <a:prstGeom prst="rect">
+            <a:avLst/>
+          </a:prstGeom>
+          <a:solidFill>
+            <a:srgbClr val="E8403E"/>
+          </a:solidFill>
+          <a:ln>
+            <a:noFill/>
+          </a:ln>
+        </p:spPr>
+        <p:style>
+          <a:lnRef idx="1">
+            <a:schemeClr val="accent1"/>
+          </a:lnRef>
+          <a:fillRef idx="3">
+            <a:schemeClr val="accent1"/>
+          </a:fillRef>
+          <a:effectRef idx="2">
+            <a:schemeClr val="accent1"/>
+          </a:effectRef>
+          <a:fontRef idx="minor">
+            <a:schemeClr val="lt1"/>
+          </a:fontRef>
+        </p:style>
+        <p:txBody>
+          <a:bodyPr rtlCol="0" anchor="ctr"/>
+          <a:lstStyle/>
+          <a:p>
+            <a:pPr algn="ctr"/>
+          </a:p>
+        </p:txBody>
+      </p:sp>
+      <p:sp>
+        <p:nvSpPr>
+          <p:cNvPr id="4" name="TextBox 3"/>
+          <p:cNvSpPr txBox="1"/>
+          <p:nvPr/>
+        </p:nvSpPr>
+        <p:spPr>
+          <a:xfrm>
+            <a:off x="914400" y="1645920"/>
+            <a:ext cx="9601200" cy="457200"/>
+          </a:xfrm>
+          <a:prstGeom prst="rect">
+            <a:avLst/>
+          </a:prstGeom>
+          <a:noFill/>
+        </p:spPr>
+        <p:txBody>
+          <a:bodyPr wrap="square">
+            <a:spAutoFit/>
+          </a:bodyPr>
+          <a:lstStyle/>
+          <a:p>
+            <a:pPr algn="l">
+              <a:defRPr sz="1600" b="0">
+                <a:solidFill>
+                  <a:srgbClr val="E5E5E5"/>
+                </a:solidFill>
+                <a:latin typeface="Calibri"/>
+              </a:defRPr>
+            </a:pPr>
+            <a:r>
+              <a:t>Filter bubbles: Content-Based has diversity of only 0.09 -- users see</a:t>
+            </a:r>
+          </a:p>
+        </p:txBody>
+      </p:sp>
+      <p:sp>
+        <p:nvSpPr>
+          <p:cNvPr id="5" name="TextBox 4"/>
+          <p:cNvSpPr txBox="1"/>
+          <p:nvPr/>
+        </p:nvSpPr>
+        <p:spPr>
+          <a:xfrm>
+            <a:off x="914400" y="2057400"/>
+            <a:ext cx="9601200" cy="457200"/>
+          </a:xfrm>
+          <a:prstGeom prst="rect">
+            <a:avLst/>
+          </a:prstGeom>
+          <a:noFill/>
+        </p:spPr>
+        <p:txBody>
+          <a:bodyPr wrap="square">
+            <a:spAutoFit/>
+          </a:bodyPr>
+          <a:lstStyle/>
+          <a:p>
+            <a:pPr algn="l">
+              <a:defRPr sz="1600" b="0">
+                <a:solidFill>
+                  <a:srgbClr val="E5E5E5"/>
+                </a:solidFill>
+                <a:latin typeface="Calibri"/>
+              </a:defRPr>
+            </a:pPr>
+            <a:r>
+              <a:t>  increasingly narrow genre profiles, limiting cultural exploration</a:t>
+            </a:r>
+          </a:p>
+        </p:txBody>
+      </p:sp>
+      <p:sp>
+        <p:nvSpPr>
+          <p:cNvPr id="6" name="TextBox 5"/>
+          <p:cNvSpPr txBox="1"/>
+          <p:nvPr/>
+        </p:nvSpPr>
+        <p:spPr>
+          <a:xfrm>
+            <a:off x="914400" y="2468880"/>
+            <a:ext cx="9601200" cy="457200"/>
+          </a:xfrm>
+          <a:prstGeom prst="rect">
+            <a:avLst/>
+          </a:prstGeom>
+          <a:noFill/>
+        </p:spPr>
+        <p:txBody>
+          <a:bodyPr wrap="square">
+            <a:spAutoFit/>
+          </a:bodyPr>
+          <a:lstStyle/>
+          <a:p>
+            <a:pPr algn="l">
+              <a:defRPr sz="1600" b="0">
+                <a:solidFill>
+                  <a:srgbClr val="E5E5E5"/>
+                </a:solidFill>
+                <a:latin typeface="Calibri"/>
+              </a:defRPr>
+            </a:pPr>
+          </a:p>
+        </p:txBody>
+      </p:sp>
+      <p:sp>
+        <p:nvSpPr>
+          <p:cNvPr id="7" name="TextBox 6"/>
+          <p:cNvSpPr txBox="1"/>
+          <p:nvPr/>
+        </p:nvSpPr>
+        <p:spPr>
+          <a:xfrm>
+            <a:off x="914400" y="2880360"/>
+            <a:ext cx="9601200" cy="457200"/>
+          </a:xfrm>
+          <a:prstGeom prst="rect">
+            <a:avLst/>
+          </a:prstGeom>
+          <a:noFill/>
+        </p:spPr>
+        <p:txBody>
+          <a:bodyPr wrap="square">
+            <a:spAutoFit/>
+          </a:bodyPr>
+          <a:lstStyle/>
+          <a:p>
+            <a:pPr algn="l">
+              <a:defRPr sz="1600" b="0">
+                <a:solidFill>
+                  <a:srgbClr val="E5E5E5"/>
+                </a:solidFill>
+                <a:latin typeface="Calibri"/>
+              </a:defRPr>
+            </a:pPr>
+            <a:r>
+              <a:t>Popularity bias amplification: Most Popular (100% pop bias) surfaces</a:t>
+            </a:r>
+          </a:p>
+        </p:txBody>
+      </p:sp>
+      <p:sp>
+        <p:nvSpPr>
+          <p:cNvPr id="8" name="TextBox 7"/>
+          <p:cNvSpPr txBox="1"/>
+          <p:nvPr/>
+        </p:nvSpPr>
+        <p:spPr>
+          <a:xfrm>
+            <a:off x="914400" y="3291840"/>
+            <a:ext cx="9601200" cy="457200"/>
+          </a:xfrm>
+          <a:prstGeom prst="rect">
+            <a:avLst/>
+          </a:prstGeom>
+          <a:noFill/>
+        </p:spPr>
+        <p:txBody>
+          <a:bodyPr wrap="square">
+            <a:spAutoFit/>
+          </a:bodyPr>
+          <a:lstStyle/>
+          <a:p>
+            <a:pPr algn="l">
+              <a:defRPr sz="1600" b="0">
+                <a:solidFill>
+                  <a:srgbClr val="E5E5E5"/>
+                </a:solidFill>
+                <a:latin typeface="Calibri"/>
+              </a:defRPr>
+            </a:pPr>
+            <a:r>
+              <a:t>  the same 60 movies to all users, marginalizing niche content</a:t>
+            </a:r>
+          </a:p>
+        </p:txBody>
+      </p:sp>
+      <p:sp>
+        <p:nvSpPr>
+          <p:cNvPr id="9" name="TextBox 8"/>
+          <p:cNvSpPr txBox="1"/>
+          <p:nvPr/>
+        </p:nvSpPr>
+        <p:spPr>
+          <a:xfrm>
+            <a:off x="914400" y="3703320"/>
+            <a:ext cx="9601200" cy="457200"/>
+          </a:xfrm>
+          <a:prstGeom prst="rect">
+            <a:avLst/>
+          </a:prstGeom>
+          <a:noFill/>
+        </p:spPr>
+        <p:txBody>
+          <a:bodyPr wrap="square">
+            <a:spAutoFit/>
+          </a:bodyPr>
+          <a:lstStyle/>
+          <a:p>
+            <a:pPr algn="l">
+              <a:defRPr sz="1600" b="0">
+                <a:solidFill>
+                  <a:srgbClr val="E5E5E5"/>
+                </a:solidFill>
+                <a:latin typeface="Calibri"/>
+              </a:defRPr>
+            </a:pPr>
+          </a:p>
+        </p:txBody>
+      </p:sp>
+      <p:sp>
+        <p:nvSpPr>
+          <p:cNvPr id="10" name="TextBox 9"/>
+          <p:cNvSpPr txBox="1"/>
+          <p:nvPr/>
+        </p:nvSpPr>
+        <p:spPr>
+          <a:xfrm>
+            <a:off x="914400" y="4114800"/>
+            <a:ext cx="9601200" cy="457200"/>
+          </a:xfrm>
+          <a:prstGeom prst="rect">
+            <a:avLst/>
+          </a:prstGeom>
+          <a:noFill/>
+        </p:spPr>
+        <p:txBody>
+          <a:bodyPr wrap="square">
+            <a:spAutoFit/>
+          </a:bodyPr>
+          <a:lstStyle/>
+          <a:p>
+            <a:pPr algn="l">
+              <a:defRPr sz="1600" b="0">
+                <a:solidFill>
+                  <a:srgbClr val="E5E5E5"/>
+                </a:solidFill>
+                <a:latin typeface="Calibri"/>
+              </a:defRPr>
+            </a:pPr>
+            <a:r>
+              <a:t>Fairness: heavy raters get 2x better NDCG than light raters (Most Pop),</a:t>
+            </a:r>
+          </a:p>
+        </p:txBody>
+      </p:sp>
+      <p:sp>
+        <p:nvSpPr>
+          <p:cNvPr id="11" name="TextBox 10"/>
+          <p:cNvSpPr txBox="1"/>
+          <p:nvPr/>
+        </p:nvSpPr>
+        <p:spPr>
+          <a:xfrm>
+            <a:off x="914400" y="4526280"/>
+            <a:ext cx="9601200" cy="457200"/>
+          </a:xfrm>
+          <a:prstGeom prst="rect">
+            <a:avLst/>
+          </a:prstGeom>
+          <a:noFill/>
+        </p:spPr>
+        <p:txBody>
+          <a:bodyPr wrap="square">
+            <a:spAutoFit/>
+          </a:bodyPr>
+          <a:lstStyle/>
+          <a:p>
+            <a:pPr algn="l">
+              <a:defRPr sz="1600" b="0">
+                <a:solidFill>
+                  <a:srgbClr val="E5E5E5"/>
+                </a:solidFill>
+                <a:latin typeface="Calibri"/>
+              </a:defRPr>
+            </a:pPr>
+            <a:r>
+              <a:t>  disadvantaging casual users who contribute fewer ratings</a:t>
+            </a:r>
+          </a:p>
+        </p:txBody>
+      </p:sp>
+      <p:sp>
+        <p:nvSpPr>
+          <p:cNvPr id="12" name="TextBox 11"/>
+          <p:cNvSpPr txBox="1"/>
+          <p:nvPr/>
+        </p:nvSpPr>
+        <p:spPr>
+          <a:xfrm>
+            <a:off x="914400" y="4937760"/>
+            <a:ext cx="9601200" cy="457200"/>
+          </a:xfrm>
+          <a:prstGeom prst="rect">
+            <a:avLst/>
+          </a:prstGeom>
+          <a:noFill/>
+        </p:spPr>
+        <p:txBody>
+          <a:bodyPr wrap="square">
+            <a:spAutoFit/>
+          </a:bodyPr>
+          <a:lstStyle/>
+          <a:p>
+            <a:pPr algn="l">
+              <a:defRPr sz="1600" b="0">
+                <a:solidFill>
+                  <a:srgbClr val="E5E5E5"/>
+                </a:solidFill>
+                <a:latin typeface="Calibri"/>
+              </a:defRPr>
+            </a:pPr>
+          </a:p>
+        </p:txBody>
+      </p:sp>
+      <p:sp>
+        <p:nvSpPr>
+          <p:cNvPr id="13" name="TextBox 12"/>
+          <p:cNvSpPr txBox="1"/>
+          <p:nvPr/>
+        </p:nvSpPr>
+        <p:spPr>
+          <a:xfrm>
+            <a:off x="914400" y="5349240"/>
+            <a:ext cx="9601200" cy="457200"/>
+          </a:xfrm>
+          <a:prstGeom prst="rect">
+            <a:avLst/>
+          </a:prstGeom>
+          <a:noFill/>
+        </p:spPr>
+        <p:txBody>
+          <a:bodyPr wrap="square">
+            <a:spAutoFit/>
+          </a:bodyPr>
+          <a:lstStyle/>
+          <a:p>
+            <a:pPr algn="l">
+              <a:defRPr sz="1600" b="0">
+                <a:solidFill>
+                  <a:srgbClr val="E5E5E5"/>
+                </a:solidFill>
+                <a:latin typeface="Calibri"/>
+              </a:defRPr>
+            </a:pPr>
+            <a:r>
+              <a:t>Privacy: CF requires storing and processing individual rating histories</a:t>
+            </a:r>
+          </a:p>
+        </p:txBody>
+      </p:sp>
+      <p:sp>
+        <p:nvSpPr>
+          <p:cNvPr id="14" name="TextBox 13"/>
+          <p:cNvSpPr txBox="1"/>
+          <p:nvPr/>
+        </p:nvSpPr>
+        <p:spPr>
+          <a:xfrm>
+            <a:off x="914400" y="5760720"/>
+            <a:ext cx="9601200" cy="457200"/>
+          </a:xfrm>
+          <a:prstGeom prst="rect">
+            <a:avLst/>
+          </a:prstGeom>
+          <a:noFill/>
+        </p:spPr>
+        <p:txBody>
+          <a:bodyPr wrap="square">
+            <a:spAutoFit/>
+          </a:bodyPr>
+          <a:lstStyle/>
+          <a:p>
+            <a:pPr algn="l">
+              <a:defRPr sz="1600" b="0">
+                <a:solidFill>
+                  <a:srgbClr val="E5E5E5"/>
+                </a:solidFill>
+                <a:latin typeface="Calibri"/>
+              </a:defRPr>
+            </a:pPr>
+            <a:r>
+              <a:t>Transparency: MF latent factors are not interpretable -- users cannot</a:t>
+            </a:r>
+          </a:p>
+        </p:txBody>
+      </p:sp>
+      <p:sp>
+        <p:nvSpPr>
+          <p:cNvPr id="15" name="TextBox 14"/>
+          <p:cNvSpPr txBox="1"/>
+          <p:nvPr/>
+        </p:nvSpPr>
+        <p:spPr>
+          <a:xfrm>
+            <a:off x="914400" y="6172200"/>
+            <a:ext cx="9601200" cy="457200"/>
+          </a:xfrm>
+          <a:prstGeom prst="rect">
+            <a:avLst/>
+          </a:prstGeom>
+          <a:noFill/>
+        </p:spPr>
+        <p:txBody>
+          <a:bodyPr wrap="square">
+            <a:spAutoFit/>
+          </a:bodyPr>
+          <a:lstStyle/>
+          <a:p>
+            <a:pPr algn="l">
+              <a:defRPr sz="1600" b="0">
+                <a:solidFill>
+                  <a:srgbClr val="E5E5E5"/>
+                </a:solidFill>
+                <a:latin typeface="Calibri"/>
+              </a:defRPr>
+            </a:pPr>
+            <a:r>
+              <a:t>  understand why a recommendation was made</a:t>
+            </a:r>
+          </a:p>
+        </p:txBody>
+      </p:sp>
+      <p:sp>
+        <p:nvSpPr>
+          <p:cNvPr id="16" name="TextBox 15"/>
+          <p:cNvSpPr txBox="1"/>
+          <p:nvPr/>
+        </p:nvSpPr>
+        <p:spPr>
+          <a:xfrm>
+            <a:off x="914400" y="6583680"/>
+            <a:ext cx="9601200" cy="457200"/>
+          </a:xfrm>
+          <a:prstGeom prst="rect">
+            <a:avLst/>
+          </a:prstGeom>
+          <a:noFill/>
+        </p:spPr>
+        <p:txBody>
+          <a:bodyPr wrap="square">
+            <a:spAutoFit/>
+          </a:bodyPr>
+          <a:lstStyle/>
+          <a:p>
+            <a:pPr algn="l">
+              <a:defRPr sz="1600" b="0">
+                <a:solidFill>
+                  <a:srgbClr val="E5E5E5"/>
+                </a:solidFill>
+                <a:latin typeface="Calibri"/>
+              </a:defRPr>
+            </a:pPr>
+            <a:r>
+              <a:t>User autonomy: users have no control over recommendation logic in this prototype</a:t>
+            </a:r>
+          </a:p>
+        </p:txBody>
+      </p:sp>
+    </p:spTree>
+  </p:cSld>
+  <p:clrMapOvr>
+    <a:masterClrMapping/>
+  </p:clrMapOvr>
+</p:sld>
+</file>
+
+<file path=ppt/slides/slide18.xml><?xml version="1.0" encoding="utf-8"?>
+<p:sld xmlns:a="http://schemas.openxmlformats.org/drawingml/2006/main" xmlns:p="http://schemas.openxmlformats.org/presentationml/2006/main" xmlns:r="http://schemas.openxmlformats.org/officeDocument/2006/relationships">
+  <p:cSld>
+    <p:bg>
+      <p:bgPr>
+        <a:solidFill>
+          <a:srgbClr val="141414"/>
+        </a:solidFill>
+        <a:effectLst/>
+      </p:bgPr>
+    </p:bg>
+    <p:spTree>
+      <p:nvGrpSpPr>
+        <p:cNvPr id="1" name=""/>
+        <p:cNvGrpSpPr/>
+        <p:nvPr/>
+      </p:nvGrpSpPr>
+      <p:grpSpPr/>
+      <p:sp>
+        <p:nvSpPr>
+          <p:cNvPr id="2" name="TextBox 1"/>
+          <p:cNvSpPr txBox="1"/>
+          <p:nvPr/>
+        </p:nvSpPr>
+        <p:spPr>
+          <a:xfrm>
+            <a:off x="731520" y="457200"/>
+            <a:ext cx="10058400" cy="914400"/>
+          </a:xfrm>
+          <a:prstGeom prst="rect">
+            <a:avLst/>
+          </a:prstGeom>
+          <a:noFill/>
+        </p:spPr>
+        <p:txBody>
+          <a:bodyPr wrap="square">
+            <a:spAutoFit/>
+          </a:bodyPr>
+          <a:lstStyle/>
+          <a:p>
+            <a:pPr algn="l">
+              <a:defRPr sz="3600" b="1">
+                <a:solidFill>
+                  <a:srgbClr val="E5E5E5"/>
+                </a:solidFill>
+                <a:latin typeface="Calibri"/>
+              </a:defRPr>
+            </a:pPr>
+            <a:r>
+              <a:t>UX &amp; PROTOTYPE</a:t>
+            </a:r>
+          </a:p>
+        </p:txBody>
+      </p:sp>
+      <p:sp>
+        <p:nvSpPr>
+          <p:cNvPr id="3" name="Rectangle 2"/>
+          <p:cNvSpPr/>
+          <p:nvPr/>
+        </p:nvSpPr>
+        <p:spPr>
+          <a:xfrm>
+            <a:off x="731520" y="1188720"/>
+            <a:ext cx="1371600" cy="54864"/>
+          </a:xfrm>
+          <a:prstGeom prst="rect">
+            <a:avLst/>
+          </a:prstGeom>
+          <a:solidFill>
+            <a:srgbClr val="E8403E"/>
+          </a:solidFill>
+          <a:ln>
+            <a:noFill/>
+          </a:ln>
+        </p:spPr>
+        <p:style>
+          <a:lnRef idx="1">
+            <a:schemeClr val="accent1"/>
+          </a:lnRef>
+          <a:fillRef idx="3">
+            <a:schemeClr val="accent1"/>
+          </a:fillRef>
+          <a:effectRef idx="2">
+            <a:schemeClr val="accent1"/>
+          </a:effectRef>
+          <a:fontRef idx="minor">
+            <a:schemeClr val="lt1"/>
+          </a:fontRef>
+        </p:style>
+        <p:txBody>
+          <a:bodyPr rtlCol="0" anchor="ctr"/>
+          <a:lstStyle/>
+          <a:p>
+            <a:pPr algn="ctr"/>
+          </a:p>
+        </p:txBody>
+      </p:sp>
+      <p:sp>
+        <p:nvSpPr>
+          <p:cNvPr id="4" name="TextBox 3"/>
+          <p:cNvSpPr txBox="1"/>
+          <p:nvPr/>
+        </p:nvSpPr>
+        <p:spPr>
+          <a:xfrm>
+            <a:off x="914400" y="1645920"/>
+            <a:ext cx="9601200" cy="457200"/>
+          </a:xfrm>
+          <a:prstGeom prst="rect">
+            <a:avLst/>
+          </a:prstGeom>
+          <a:noFill/>
+        </p:spPr>
+        <p:txBody>
+          <a:bodyPr wrap="square">
+            <a:spAutoFit/>
+          </a:bodyPr>
+          <a:lstStyle/>
+          <a:p>
+            <a:pPr algn="l">
+              <a:defRPr sz="1600" b="0">
+                <a:solidFill>
+                  <a:srgbClr val="E5E5E5"/>
+                </a:solidFill>
+                <a:latin typeface="Calibri"/>
+              </a:defRPr>
+            </a:pPr>
+            <a:r>
+              <a:t>Netflix-inspired Streamlit UI with 6 pages</a:t>
+            </a:r>
+          </a:p>
+        </p:txBody>
+      </p:sp>
+      <p:sp>
+        <p:nvSpPr>
+          <p:cNvPr id="5" name="TextBox 4"/>
+          <p:cNvSpPr txBox="1"/>
+          <p:nvPr/>
+        </p:nvSpPr>
+        <p:spPr>
+          <a:xfrm>
+            <a:off x="914400" y="2057400"/>
+            <a:ext cx="9601200" cy="457200"/>
+          </a:xfrm>
+          <a:prstGeom prst="rect">
+            <a:avLst/>
+          </a:prstGeom>
+          <a:noFill/>
+        </p:spPr>
+        <p:txBody>
+          <a:bodyPr wrap="square">
+            <a:spAutoFit/>
+          </a:bodyPr>
+          <a:lstStyle/>
+          <a:p>
+            <a:pPr algn="l">
+              <a:defRPr sz="1600" b="0">
+                <a:solidFill>
+                  <a:srgbClr val="E5E5E5"/>
+                </a:solidFill>
+                <a:latin typeface="Calibri"/>
+              </a:defRPr>
+            </a:pPr>
+            <a:r>
+              <a:t>Design: dark theme (#141414), consistent with CineMatch brand identity</a:t>
+            </a:r>
+          </a:p>
+        </p:txBody>
+      </p:sp>
+      <p:sp>
+        <p:nvSpPr>
+          <p:cNvPr id="6" name="TextBox 5"/>
+          <p:cNvSpPr txBox="1"/>
+          <p:nvPr/>
+        </p:nvSpPr>
+        <p:spPr>
+          <a:xfrm>
+            <a:off x="914400" y="2468880"/>
+            <a:ext cx="9601200" cy="457200"/>
+          </a:xfrm>
+          <a:prstGeom prst="rect">
+            <a:avLst/>
+          </a:prstGeom>
+          <a:noFill/>
+        </p:spPr>
+        <p:txBody>
+          <a:bodyPr wrap="square">
+            <a:spAutoFit/>
+          </a:bodyPr>
+          <a:lstStyle/>
+          <a:p>
+            <a:pPr algn="l">
+              <a:defRPr sz="1600" b="0">
+                <a:solidFill>
+                  <a:srgbClr val="E5E5E5"/>
+                </a:solidFill>
+                <a:latin typeface="Calibri"/>
+              </a:defRPr>
+            </a:pPr>
+            <a:r>
+              <a:t>Poster lazy loading via TMDb API with JSON cache</a:t>
+            </a:r>
+          </a:p>
+        </p:txBody>
+      </p:sp>
+      <p:sp>
+        <p:nvSpPr>
+          <p:cNvPr id="7" name="TextBox 6"/>
+          <p:cNvSpPr txBox="1"/>
+          <p:nvPr/>
+        </p:nvSpPr>
+        <p:spPr>
+          <a:xfrm>
+            <a:off x="914400" y="2880360"/>
+            <a:ext cx="9601200" cy="457200"/>
+          </a:xfrm>
+          <a:prstGeom prst="rect">
+            <a:avLst/>
+          </a:prstGeom>
+          <a:noFill/>
+        </p:spPr>
+        <p:txBody>
+          <a:bodyPr wrap="square">
+            <a:spAutoFit/>
+          </a:bodyPr>
+          <a:lstStyle/>
+          <a:p>
+            <a:pPr algn="l">
+              <a:defRPr sz="1600" b="0">
+                <a:solidFill>
+                  <a:srgbClr val="E5E5E5"/>
+                </a:solidFill>
+                <a:latin typeface="Calibri"/>
+              </a:defRPr>
+            </a:pPr>
+          </a:p>
+        </p:txBody>
+      </p:sp>
+      <p:sp>
+        <p:nvSpPr>
+          <p:cNvPr id="8" name="TextBox 7"/>
+          <p:cNvSpPr txBox="1"/>
+          <p:nvPr/>
+        </p:nvSpPr>
+        <p:spPr>
+          <a:xfrm>
+            <a:off x="914400" y="3291840"/>
+            <a:ext cx="9601200" cy="457200"/>
+          </a:xfrm>
+          <a:prstGeom prst="rect">
+            <a:avLst/>
+          </a:prstGeom>
+          <a:noFill/>
+        </p:spPr>
+        <p:txBody>
+          <a:bodyPr wrap="square">
+            <a:spAutoFit/>
+          </a:bodyPr>
+          <a:lstStyle/>
+          <a:p>
+            <a:pPr algn="l">
+              <a:defRPr sz="1600" b="0">
+                <a:solidFill>
+                  <a:srgbClr val="E5E5E5"/>
+                </a:solidFill>
+                <a:latin typeface="Calibri"/>
+              </a:defRPr>
+            </a:pPr>
+            <a:r>
+              <a:t>Pages: Home (hero + trending), Discover (search + filter + similar),</a:t>
+            </a:r>
+          </a:p>
+        </p:txBody>
+      </p:sp>
+      <p:sp>
+        <p:nvSpPr>
+          <p:cNvPr id="9" name="TextBox 8"/>
+          <p:cNvSpPr txBox="1"/>
+          <p:nvPr/>
+        </p:nvSpPr>
+        <p:spPr>
+          <a:xfrm>
+            <a:off x="914400" y="3703320"/>
+            <a:ext cx="9601200" cy="457200"/>
+          </a:xfrm>
+          <a:prstGeom prst="rect">
+            <a:avLst/>
+          </a:prstGeom>
+          <a:noFill/>
+        </p:spPr>
+        <p:txBody>
+          <a:bodyPr wrap="square">
+            <a:spAutoFit/>
+          </a:bodyPr>
+          <a:lstStyle/>
+          <a:p>
+            <a:pPr algn="l">
+              <a:defRPr sz="1600" b="0">
+                <a:solidFill>
+                  <a:srgbClr val="E5E5E5"/>
+                </a:solidFill>
+                <a:latin typeface="Calibri"/>
+              </a:defRPr>
+            </a:pPr>
+            <a:r>
+              <a:t>  Recommendations (7 algorithms), User Profile (stats + genre radar),</a:t>
+            </a:r>
+          </a:p>
+        </p:txBody>
+      </p:sp>
+      <p:sp>
+        <p:nvSpPr>
+          <p:cNvPr id="10" name="TextBox 9"/>
+          <p:cNvSpPr txBox="1"/>
+          <p:nvPr/>
+        </p:nvSpPr>
+        <p:spPr>
+          <a:xfrm>
+            <a:off x="914400" y="4114800"/>
+            <a:ext cx="9601200" cy="457200"/>
+          </a:xfrm>
+          <a:prstGeom prst="rect">
+            <a:avLst/>
+          </a:prstGeom>
+          <a:noFill/>
+        </p:spPr>
+        <p:txBody>
+          <a:bodyPr wrap="square">
+            <a:spAutoFit/>
+          </a:bodyPr>
+          <a:lstStyle/>
+          <a:p>
+            <a:pPr algn="l">
+              <a:defRPr sz="1600" b="0">
+                <a:solidFill>
+                  <a:srgbClr val="E5E5E5"/>
+                </a:solidFill>
+                <a:latin typeface="Calibri"/>
+              </a:defRPr>
+            </a:pPr>
+            <a:r>
+              <a:t>  Compare (side-by-side with overlap heatmap), Evaluation (full metrics)</a:t>
+            </a:r>
+          </a:p>
+        </p:txBody>
+      </p:sp>
+      <p:sp>
+        <p:nvSpPr>
+          <p:cNvPr id="11" name="TextBox 10"/>
+          <p:cNvSpPr txBox="1"/>
+          <p:nvPr/>
+        </p:nvSpPr>
+        <p:spPr>
+          <a:xfrm>
+            <a:off x="914400" y="4526280"/>
+            <a:ext cx="9601200" cy="457200"/>
+          </a:xfrm>
+          <a:prstGeom prst="rect">
+            <a:avLst/>
+          </a:prstGeom>
+          <a:noFill/>
+        </p:spPr>
+        <p:txBody>
+          <a:bodyPr wrap="square">
+            <a:spAutoFit/>
+          </a:bodyPr>
+          <a:lstStyle/>
+          <a:p>
+            <a:pPr algn="l">
+              <a:defRPr sz="1600" b="0">
+                <a:solidFill>
+                  <a:srgbClr val="E5E5E5"/>
+                </a:solidFill>
+                <a:latin typeface="Calibri"/>
+              </a:defRPr>
+            </a:pPr>
+          </a:p>
+        </p:txBody>
+      </p:sp>
+      <p:sp>
+        <p:nvSpPr>
+          <p:cNvPr id="12" name="TextBox 11"/>
+          <p:cNvSpPr txBox="1"/>
+          <p:nvPr/>
+        </p:nvSpPr>
+        <p:spPr>
+          <a:xfrm>
+            <a:off x="914400" y="4937760"/>
+            <a:ext cx="9601200" cy="457200"/>
+          </a:xfrm>
+          <a:prstGeom prst="rect">
+            <a:avLst/>
+          </a:prstGeom>
+          <a:noFill/>
+        </p:spPr>
+        <p:txBody>
+          <a:bodyPr wrap="square">
+            <a:spAutoFit/>
+          </a:bodyPr>
+          <a:lstStyle/>
+          <a:p>
+            <a:pPr algn="l">
+              <a:defRPr sz="1600" b="0">
+                <a:solidFill>
+                  <a:srgbClr val="E5E5E5"/>
+                </a:solidFill>
+                <a:latin typeface="Calibri"/>
+              </a:defRPr>
+            </a:pPr>
+            <a:r>
+              <a:t>Poster cards with hover overlay showing title, year, genres, and 'why'</a:t>
+            </a:r>
+          </a:p>
+        </p:txBody>
+      </p:sp>
+      <p:sp>
+        <p:nvSpPr>
+          <p:cNvPr id="13" name="TextBox 12"/>
+          <p:cNvSpPr txBox="1"/>
+          <p:nvPr/>
+        </p:nvSpPr>
+        <p:spPr>
+          <a:xfrm>
+            <a:off x="914400" y="5349240"/>
+            <a:ext cx="9601200" cy="457200"/>
+          </a:xfrm>
+          <a:prstGeom prst="rect">
+            <a:avLst/>
+          </a:prstGeom>
+          <a:noFill/>
+        </p:spPr>
+        <p:txBody>
+          <a:bodyPr wrap="square">
+            <a:spAutoFit/>
+          </a:bodyPr>
+          <a:lstStyle/>
+          <a:p>
+            <a:pPr algn="l">
+              <a:defRPr sz="1600" b="0">
+                <a:solidFill>
+                  <a:srgbClr val="E5E5E5"/>
+                </a:solidFill>
+                <a:latin typeface="Calibri"/>
+              </a:defRPr>
+            </a:pPr>
+            <a:r>
+              <a:t>Horizontal scroll rows mimicking Netflix filmstrip UX</a:t>
+            </a:r>
+          </a:p>
+        </p:txBody>
+      </p:sp>
+    </p:spTree>
+  </p:cSld>
+  <p:clrMapOvr>
+    <a:masterClrMapping/>
+  </p:clrMapOvr>
+</p:sld>
+</file>
+
+<file path=ppt/slides/slide19.xml><?xml version="1.0" encoding="utf-8"?>
+<p:sld xmlns:a="http://schemas.openxmlformats.org/drawingml/2006/main" xmlns:p="http://schemas.openxmlformats.org/presentationml/2006/main" xmlns:r="http://schemas.openxmlformats.org/officeDocument/2006/relationships">
+  <p:cSld>
+    <p:bg>
+      <p:bgPr>
+        <a:solidFill>
+          <a:srgbClr val="141414"/>
+        </a:solidFill>
+        <a:effectLst/>
+      </p:bgPr>
+    </p:bg>
+    <p:spTree>
+      <p:nvGrpSpPr>
+        <p:cNvPr id="1" name=""/>
+        <p:cNvGrpSpPr/>
+        <p:nvPr/>
+      </p:nvGrpSpPr>
+      <p:grpSpPr/>
+      <p:sp>
+        <p:nvSpPr>
+          <p:cNvPr id="2" name="TextBox 1"/>
+          <p:cNvSpPr txBox="1"/>
+          <p:nvPr/>
+        </p:nvSpPr>
+        <p:spPr>
+          <a:xfrm>
+            <a:off x="731520" y="457200"/>
+            <a:ext cx="10058400" cy="914400"/>
+          </a:xfrm>
+          <a:prstGeom prst="rect">
+            <a:avLst/>
+          </a:prstGeom>
+          <a:noFill/>
+        </p:spPr>
+        <p:txBody>
+          <a:bodyPr wrap="square">
+            <a:spAutoFit/>
+          </a:bodyPr>
+          <a:lstStyle/>
+          <a:p>
+            <a:pPr algn="l">
+              <a:defRPr sz="3600" b="1">
+                <a:solidFill>
+                  <a:srgbClr val="E5E5E5"/>
+                </a:solidFill>
+                <a:latin typeface="Calibri"/>
+              </a:defRPr>
+            </a:pPr>
+            <a:r>
+              <a:t>FUTURE WORK</a:t>
+            </a:r>
+          </a:p>
+        </p:txBody>
+      </p:sp>
+      <p:sp>
+        <p:nvSpPr>
+          <p:cNvPr id="3" name="Rectangle 2"/>
+          <p:cNvSpPr/>
+          <p:nvPr/>
+        </p:nvSpPr>
+        <p:spPr>
+          <a:xfrm>
+            <a:off x="731520" y="1188720"/>
+            <a:ext cx="1371600" cy="54864"/>
+          </a:xfrm>
+          <a:prstGeom prst="rect">
+            <a:avLst/>
+          </a:prstGeom>
+          <a:solidFill>
+            <a:srgbClr val="E8403E"/>
+          </a:solidFill>
+          <a:ln>
+            <a:noFill/>
+          </a:ln>
+        </p:spPr>
+        <p:style>
+          <a:lnRef idx="1">
+            <a:schemeClr val="accent1"/>
+          </a:lnRef>
+          <a:fillRef idx="3">
+            <a:schemeClr val="accent1"/>
+          </a:fillRef>
+          <a:effectRef idx="2">
+            <a:schemeClr val="accent1"/>
+          </a:effectRef>
+          <a:fontRef idx="minor">
+            <a:schemeClr val="lt1"/>
+          </a:fontRef>
+        </p:style>
+        <p:txBody>
+          <a:bodyPr rtlCol="0" anchor="ctr"/>
+          <a:lstStyle/>
+          <a:p>
+            <a:pPr algn="ctr"/>
+          </a:p>
+        </p:txBody>
+      </p:sp>
+      <p:sp>
+        <p:nvSpPr>
+          <p:cNvPr id="4" name="TextBox 3"/>
+          <p:cNvSpPr txBox="1"/>
+          <p:nvPr/>
+        </p:nvSpPr>
+        <p:spPr>
+          <a:xfrm>
+            <a:off x="914400" y="1645920"/>
+            <a:ext cx="9601200" cy="457200"/>
+          </a:xfrm>
+          <a:prstGeom prst="rect">
+            <a:avLst/>
+          </a:prstGeom>
+          <a:noFill/>
+        </p:spPr>
+        <p:txBody>
+          <a:bodyPr wrap="square">
+            <a:spAutoFit/>
+          </a:bodyPr>
+          <a:lstStyle/>
+          <a:p>
+            <a:pPr algn="l">
+              <a:defRPr sz="1600" b="0">
+                <a:solidFill>
+                  <a:srgbClr val="E5E5E5"/>
+                </a:solidFill>
+                <a:latin typeface="Calibri"/>
+              </a:defRPr>
+            </a:pPr>
+            <a:r>
+              <a:t>Hybrid model (CF + Content-Based): combine MF's personalized ranking</a:t>
+            </a:r>
+          </a:p>
+        </p:txBody>
+      </p:sp>
+      <p:sp>
+        <p:nvSpPr>
+          <p:cNvPr id="5" name="TextBox 4"/>
+          <p:cNvSpPr txBox="1"/>
+          <p:nvPr/>
+        </p:nvSpPr>
+        <p:spPr>
+          <a:xfrm>
+            <a:off x="914400" y="2057400"/>
+            <a:ext cx="9601200" cy="457200"/>
+          </a:xfrm>
+          <a:prstGeom prst="rect">
+            <a:avLst/>
+          </a:prstGeom>
+          <a:noFill/>
+        </p:spPr>
+        <p:txBody>
+          <a:bodyPr wrap="square">
+            <a:spAutoFit/>
+          </a:bodyPr>
+          <a:lstStyle/>
+          <a:p>
+            <a:pPr algn="l">
+              <a:defRPr sz="1600" b="0">
+                <a:solidFill>
+                  <a:srgbClr val="E5E5E5"/>
+                </a:solidFill>
+                <a:latin typeface="Calibri"/>
+              </a:defRPr>
+            </a:pPr>
+            <a:r>
+              <a:t>  with CB's item features to address both cold-start and sparsity</a:t>
+            </a:r>
+          </a:p>
+        </p:txBody>
+      </p:sp>
+      <p:sp>
+        <p:nvSpPr>
+          <p:cNvPr id="6" name="TextBox 5"/>
+          <p:cNvSpPr txBox="1"/>
+          <p:nvPr/>
+        </p:nvSpPr>
+        <p:spPr>
+          <a:xfrm>
+            <a:off x="914400" y="2468880"/>
+            <a:ext cx="9601200" cy="457200"/>
+          </a:xfrm>
+          <a:prstGeom prst="rect">
+            <a:avLst/>
+          </a:prstGeom>
+          <a:noFill/>
+        </p:spPr>
+        <p:txBody>
+          <a:bodyPr wrap="square">
+            <a:spAutoFit/>
+          </a:bodyPr>
+          <a:lstStyle/>
+          <a:p>
+            <a:pPr algn="l">
+              <a:defRPr sz="1600" b="0">
+                <a:solidFill>
+                  <a:srgbClr val="E5E5E5"/>
+                </a:solidFill>
+                <a:latin typeface="Calibri"/>
+              </a:defRPr>
+            </a:pPr>
+          </a:p>
+        </p:txBody>
+      </p:sp>
+      <p:sp>
+        <p:nvSpPr>
+          <p:cNvPr id="7" name="TextBox 6"/>
+          <p:cNvSpPr txBox="1"/>
+          <p:nvPr/>
+        </p:nvSpPr>
+        <p:spPr>
+          <a:xfrm>
+            <a:off x="914400" y="2880360"/>
+            <a:ext cx="9601200" cy="457200"/>
+          </a:xfrm>
+          <a:prstGeom prst="rect">
+            <a:avLst/>
+          </a:prstGeom>
+          <a:noFill/>
+        </p:spPr>
+        <p:txBody>
+          <a:bodyPr wrap="square">
+            <a:spAutoFit/>
+          </a:bodyPr>
+          <a:lstStyle/>
+          <a:p>
+            <a:pPr algn="l">
+              <a:defRPr sz="1600" b="0">
+                <a:solidFill>
+                  <a:srgbClr val="E5E5E5"/>
+                </a:solidFill>
+                <a:latin typeface="Calibri"/>
+              </a:defRPr>
+            </a:pPr>
+            <a:r>
+              <a:t>Online learning: update latent factors incrementally as new ratings</a:t>
+            </a:r>
+          </a:p>
+        </p:txBody>
+      </p:sp>
+      <p:sp>
+        <p:nvSpPr>
+          <p:cNvPr id="8" name="TextBox 7"/>
+          <p:cNvSpPr txBox="1"/>
+          <p:nvPr/>
+        </p:nvSpPr>
+        <p:spPr>
+          <a:xfrm>
+            <a:off x="914400" y="3291840"/>
+            <a:ext cx="9601200" cy="457200"/>
+          </a:xfrm>
+          <a:prstGeom prst="rect">
+            <a:avLst/>
+          </a:prstGeom>
+          <a:noFill/>
+        </p:spPr>
+        <p:txBody>
+          <a:bodyPr wrap="square">
+            <a:spAutoFit/>
+          </a:bodyPr>
+          <a:lstStyle/>
+          <a:p>
+            <a:pPr algn="l">
+              <a:defRPr sz="1600" b="0">
+                <a:solidFill>
+                  <a:srgbClr val="E5E5E5"/>
+                </a:solidFill>
+                <a:latin typeface="Calibri"/>
+              </a:defRPr>
+            </a:pPr>
+            <a:r>
+              <a:t>  arrive, instead of full retraining (critical for production deployment)</a:t>
+            </a:r>
+          </a:p>
+        </p:txBody>
+      </p:sp>
+      <p:sp>
+        <p:nvSpPr>
+          <p:cNvPr id="9" name="TextBox 8"/>
+          <p:cNvSpPr txBox="1"/>
+          <p:nvPr/>
+        </p:nvSpPr>
+        <p:spPr>
+          <a:xfrm>
+            <a:off x="914400" y="3703320"/>
+            <a:ext cx="9601200" cy="457200"/>
+          </a:xfrm>
+          <a:prstGeom prst="rect">
+            <a:avLst/>
+          </a:prstGeom>
+          <a:noFill/>
+        </p:spPr>
+        <p:txBody>
+          <a:bodyPr wrap="square">
+            <a:spAutoFit/>
+          </a:bodyPr>
+          <a:lstStyle/>
+          <a:p>
+            <a:pPr algn="l">
+              <a:defRPr sz="1600" b="0">
+                <a:solidFill>
+                  <a:srgbClr val="E5E5E5"/>
+                </a:solidFill>
+                <a:latin typeface="Calibri"/>
+              </a:defRPr>
+            </a:pPr>
+          </a:p>
+        </p:txBody>
+      </p:sp>
+      <p:sp>
+        <p:nvSpPr>
+          <p:cNvPr id="10" name="TextBox 9"/>
+          <p:cNvSpPr txBox="1"/>
+          <p:nvPr/>
+        </p:nvSpPr>
+        <p:spPr>
+          <a:xfrm>
+            <a:off x="914400" y="4114800"/>
+            <a:ext cx="9601200" cy="457200"/>
+          </a:xfrm>
+          <a:prstGeom prst="rect">
+            <a:avLst/>
+          </a:prstGeom>
+          <a:noFill/>
+        </p:spPr>
+        <p:txBody>
+          <a:bodyPr wrap="square">
+            <a:spAutoFit/>
+          </a:bodyPr>
+          <a:lstStyle/>
+          <a:p>
+            <a:pPr algn="l">
+              <a:defRPr sz="1600" b="0">
+                <a:solidFill>
+                  <a:srgbClr val="E5E5E5"/>
+                </a:solidFill>
+                <a:latin typeface="Calibri"/>
+              </a:defRPr>
+            </a:pPr>
+            <a:r>
+              <a:t>A/B testing framework: measure real user engagement (clicks, watch time),</a:t>
+            </a:r>
+          </a:p>
+        </p:txBody>
+      </p:sp>
+      <p:sp>
+        <p:nvSpPr>
+          <p:cNvPr id="11" name="TextBox 10"/>
+          <p:cNvSpPr txBox="1"/>
+          <p:nvPr/>
+        </p:nvSpPr>
+        <p:spPr>
+          <a:xfrm>
+            <a:off x="914400" y="4526280"/>
+            <a:ext cx="9601200" cy="457200"/>
+          </a:xfrm>
+          <a:prstGeom prst="rect">
+            <a:avLst/>
+          </a:prstGeom>
+          <a:noFill/>
+        </p:spPr>
+        <p:txBody>
+          <a:bodyPr wrap="square">
+            <a:spAutoFit/>
+          </a:bodyPr>
+          <a:lstStyle/>
+          <a:p>
+            <a:pPr algn="l">
+              <a:defRPr sz="1600" b="0">
+                <a:solidFill>
+                  <a:srgbClr val="E5E5E5"/>
+                </a:solidFill>
+                <a:latin typeface="Calibri"/>
+              </a:defRPr>
+            </a:pPr>
+            <a:r>
+              <a:t>  not just offline metrics -- offline P@10 does not predict user satisfaction</a:t>
+            </a:r>
+          </a:p>
+        </p:txBody>
+      </p:sp>
+      <p:sp>
+        <p:nvSpPr>
+          <p:cNvPr id="12" name="TextBox 11"/>
+          <p:cNvSpPr txBox="1"/>
+          <p:nvPr/>
+        </p:nvSpPr>
+        <p:spPr>
+          <a:xfrm>
+            <a:off x="914400" y="4937760"/>
+            <a:ext cx="9601200" cy="457200"/>
+          </a:xfrm>
+          <a:prstGeom prst="rect">
+            <a:avLst/>
+          </a:prstGeom>
+          <a:noFill/>
+        </p:spPr>
+        <p:txBody>
+          <a:bodyPr wrap="square">
+            <a:spAutoFit/>
+          </a:bodyPr>
+          <a:lstStyle/>
+          <a:p>
+            <a:pPr algn="l">
+              <a:defRPr sz="1600" b="0">
+                <a:solidFill>
+                  <a:srgbClr val="E5E5E5"/>
+                </a:solidFill>
+                <a:latin typeface="Calibri"/>
+              </a:defRPr>
+            </a:pPr>
+          </a:p>
+        </p:txBody>
+      </p:sp>
+      <p:sp>
+        <p:nvSpPr>
+          <p:cNvPr id="13" name="TextBox 12"/>
+          <p:cNvSpPr txBox="1"/>
+          <p:nvPr/>
+        </p:nvSpPr>
+        <p:spPr>
+          <a:xfrm>
+            <a:off x="914400" y="5349240"/>
+            <a:ext cx="9601200" cy="457200"/>
+          </a:xfrm>
+          <a:prstGeom prst="rect">
+            <a:avLst/>
+          </a:prstGeom>
+          <a:noFill/>
+        </p:spPr>
+        <p:txBody>
+          <a:bodyPr wrap="square">
+            <a:spAutoFit/>
+          </a:bodyPr>
+          <a:lstStyle/>
+          <a:p>
+            <a:pPr algn="l">
+              <a:defRPr sz="1600" b="0">
+                <a:solidFill>
+                  <a:srgbClr val="E5E5E5"/>
+                </a:solidFill>
+                <a:latin typeface="Calibri"/>
+              </a:defRPr>
+            </a:pPr>
+            <a:r>
+              <a:t>Explicit debiasing: re-rank to enforce minimum diversity/coverage constraints</a:t>
+            </a:r>
+          </a:p>
+        </p:txBody>
+      </p:sp>
+      <p:sp>
+        <p:nvSpPr>
+          <p:cNvPr id="14" name="TextBox 13"/>
+          <p:cNvSpPr txBox="1"/>
+          <p:nvPr/>
+        </p:nvSpPr>
+        <p:spPr>
+          <a:xfrm>
+            <a:off x="914400" y="5760720"/>
+            <a:ext cx="9601200" cy="457200"/>
+          </a:xfrm>
+          <a:prstGeom prst="rect">
+            <a:avLst/>
+          </a:prstGeom>
+          <a:noFill/>
+        </p:spPr>
+        <p:txBody>
+          <a:bodyPr wrap="square">
+            <a:spAutoFit/>
+          </a:bodyPr>
+          <a:lstStyle/>
+          <a:p>
+            <a:pPr algn="l">
+              <a:defRPr sz="1600" b="0">
+                <a:solidFill>
+                  <a:srgbClr val="E5E5E5"/>
+                </a:solidFill>
+                <a:latin typeface="Calibri"/>
+              </a:defRPr>
+            </a:pPr>
+            <a:r>
+              <a:t>All four target the identified weaknesses: cold-start, sparsity, pop bias, offline gap</a:t>
             </a:r>
           </a:p>
         </p:txBody>
@@ -5259,7 +6847,7 @@
               </a:defRPr>
             </a:pPr>
             <a:r>
-              <a:t>1. Problem &amp; Dataset</a:t>
+              <a:t>1.  Problem &amp; Dataset</a:t>
             </a:r>
           </a:p>
         </p:txBody>
@@ -5295,7 +6883,7 @@
               </a:defRPr>
             </a:pPr>
             <a:r>
-              <a:t>2. Non-Personalized Baselines</a:t>
+              <a:t>2.  Non-Personalized Baselines</a:t>
             </a:r>
           </a:p>
         </p:txBody>
@@ -5331,7 +6919,7 @@
               </a:defRPr>
             </a:pPr>
             <a:r>
-              <a:t>3. Content-Based Filtering (TF-IDF)</a:t>
+              <a:t>3.  Content-Based Filtering (TF-IDF)</a:t>
             </a:r>
           </a:p>
         </p:txBody>
@@ -5367,7 +6955,7 @@
               </a:defRPr>
             </a:pPr>
             <a:r>
-              <a:t>4. Collaborative Filtering (User-User &amp; Item-Item)</a:t>
+              <a:t>4.  Collaborative Filtering (User-User &amp; Item-Item)</a:t>
             </a:r>
           </a:p>
         </p:txBody>
@@ -5403,7 +6991,7 @@
               </a:defRPr>
             </a:pPr>
             <a:r>
-              <a:t>5. Matrix Factorization (Biased SGD)</a:t>
+              <a:t>5.  Matrix Factorization (Biased SGD)</a:t>
             </a:r>
           </a:p>
         </p:txBody>
@@ -5439,7 +7027,7 @@
               </a:defRPr>
             </a:pPr>
             <a:r>
-              <a:t>6. Evaluation: Accuracy Metrics</a:t>
+              <a:t>6.  Evaluation: Accuracy, Beyond Accuracy, Trade-offs</a:t>
             </a:r>
           </a:p>
         </p:txBody>
@@ -5475,7 +7063,7 @@
               </a:defRPr>
             </a:pPr>
             <a:r>
-              <a:t>7. Evaluation: Beyond Accuracy</a:t>
+              <a:t>7.  Technical Challenges &amp; Limitations</a:t>
             </a:r>
           </a:p>
         </p:txBody>
@@ -5511,7 +7099,7 @@
               </a:defRPr>
             </a:pPr>
             <a:r>
-              <a:t>8. Trade-off Analysis &amp; Fairness</a:t>
+              <a:t>8.  Ethical &amp; Social Implications</a:t>
             </a:r>
           </a:p>
         </p:txBody>
@@ -5547,7 +7135,7 @@
               </a:defRPr>
             </a:pPr>
             <a:r>
-              <a:t>9. UX &amp; Prototype Demo</a:t>
+              <a:t>9.  UX &amp; Prototype Demo</a:t>
             </a:r>
           </a:p>
         </p:txBody>
@@ -5583,7 +7171,571 @@
               </a:defRPr>
             </a:pPr>
             <a:r>
-              <a:t>10. Conclusions &amp; Lessons Learned</a:t>
+              <a:t>10. Conclusions, Future Work &amp; Final Remarks</a:t>
+            </a:r>
+          </a:p>
+        </p:txBody>
+      </p:sp>
+    </p:spTree>
+  </p:cSld>
+  <p:clrMapOvr>
+    <a:masterClrMapping/>
+  </p:clrMapOvr>
+</p:sld>
+</file>
+
+<file path=ppt/slides/slide20.xml><?xml version="1.0" encoding="utf-8"?>
+<p:sld xmlns:a="http://schemas.openxmlformats.org/drawingml/2006/main" xmlns:p="http://schemas.openxmlformats.org/presentationml/2006/main" xmlns:r="http://schemas.openxmlformats.org/officeDocument/2006/relationships">
+  <p:cSld>
+    <p:bg>
+      <p:bgPr>
+        <a:solidFill>
+          <a:srgbClr val="141414"/>
+        </a:solidFill>
+        <a:effectLst/>
+      </p:bgPr>
+    </p:bg>
+    <p:spTree>
+      <p:nvGrpSpPr>
+        <p:cNvPr id="1" name=""/>
+        <p:cNvGrpSpPr/>
+        <p:nvPr/>
+      </p:nvGrpSpPr>
+      <p:grpSpPr/>
+      <p:sp>
+        <p:nvSpPr>
+          <p:cNvPr id="2" name="TextBox 1"/>
+          <p:cNvSpPr txBox="1"/>
+          <p:nvPr/>
+        </p:nvSpPr>
+        <p:spPr>
+          <a:xfrm>
+            <a:off x="731520" y="457200"/>
+            <a:ext cx="10058400" cy="914400"/>
+          </a:xfrm>
+          <a:prstGeom prst="rect">
+            <a:avLst/>
+          </a:prstGeom>
+          <a:noFill/>
+        </p:spPr>
+        <p:txBody>
+          <a:bodyPr wrap="square">
+            <a:spAutoFit/>
+          </a:bodyPr>
+          <a:lstStyle/>
+          <a:p>
+            <a:pPr algn="l">
+              <a:defRPr sz="3600" b="1">
+                <a:solidFill>
+                  <a:srgbClr val="E5E5E5"/>
+                </a:solidFill>
+                <a:latin typeface="Calibri"/>
+              </a:defRPr>
+            </a:pPr>
+            <a:r>
+              <a:t>FINAL REMARKS</a:t>
+            </a:r>
+          </a:p>
+        </p:txBody>
+      </p:sp>
+      <p:sp>
+        <p:nvSpPr>
+          <p:cNvPr id="3" name="Rectangle 2"/>
+          <p:cNvSpPr/>
+          <p:nvPr/>
+        </p:nvSpPr>
+        <p:spPr>
+          <a:xfrm>
+            <a:off x="731520" y="1188720"/>
+            <a:ext cx="1371600" cy="54864"/>
+          </a:xfrm>
+          <a:prstGeom prst="rect">
+            <a:avLst/>
+          </a:prstGeom>
+          <a:solidFill>
+            <a:srgbClr val="E8403E"/>
+          </a:solidFill>
+          <a:ln>
+            <a:noFill/>
+          </a:ln>
+        </p:spPr>
+        <p:style>
+          <a:lnRef idx="1">
+            <a:schemeClr val="accent1"/>
+          </a:lnRef>
+          <a:fillRef idx="3">
+            <a:schemeClr val="accent1"/>
+          </a:fillRef>
+          <a:effectRef idx="2">
+            <a:schemeClr val="accent1"/>
+          </a:effectRef>
+          <a:fontRef idx="minor">
+            <a:schemeClr val="lt1"/>
+          </a:fontRef>
+        </p:style>
+        <p:txBody>
+          <a:bodyPr rtlCol="0" anchor="ctr"/>
+          <a:lstStyle/>
+          <a:p>
+            <a:pPr algn="ctr"/>
+          </a:p>
+        </p:txBody>
+      </p:sp>
+      <p:sp>
+        <p:nvSpPr>
+          <p:cNvPr id="4" name="TextBox 3"/>
+          <p:cNvSpPr txBox="1"/>
+          <p:nvPr/>
+        </p:nvSpPr>
+        <p:spPr>
+          <a:xfrm>
+            <a:off x="914400" y="1645920"/>
+            <a:ext cx="9601200" cy="457200"/>
+          </a:xfrm>
+          <a:prstGeom prst="rect">
+            <a:avLst/>
+          </a:prstGeom>
+          <a:noFill/>
+        </p:spPr>
+        <p:txBody>
+          <a:bodyPr wrap="square">
+            <a:spAutoFit/>
+          </a:bodyPr>
+          <a:lstStyle/>
+          <a:p>
+            <a:pPr algn="l">
+              <a:defRPr sz="1600" b="0">
+                <a:solidFill>
+                  <a:srgbClr val="E5E5E5"/>
+                </a:solidFill>
+                <a:latin typeface="Calibri"/>
+              </a:defRPr>
+            </a:pPr>
+            <a:r>
+              <a:t>All formulas implemented exactly as in Prof. Torrens' lecture slides (verified audit)</a:t>
+            </a:r>
+          </a:p>
+        </p:txBody>
+      </p:sp>
+      <p:sp>
+        <p:nvSpPr>
+          <p:cNvPr id="5" name="TextBox 4"/>
+          <p:cNvSpPr txBox="1"/>
+          <p:nvPr/>
+        </p:nvSpPr>
+        <p:spPr>
+          <a:xfrm>
+            <a:off x="914400" y="2057400"/>
+            <a:ext cx="9601200" cy="457200"/>
+          </a:xfrm>
+          <a:prstGeom prst="rect">
+            <a:avLst/>
+          </a:prstGeom>
+          <a:noFill/>
+        </p:spPr>
+        <p:txBody>
+          <a:bodyPr wrap="square">
+            <a:spAutoFit/>
+          </a:bodyPr>
+          <a:lstStyle/>
+          <a:p>
+            <a:pPr algn="l">
+              <a:defRPr sz="1600" b="0">
+                <a:solidFill>
+                  <a:srgbClr val="E5E5E5"/>
+                </a:solidFill>
+                <a:latin typeface="Calibri"/>
+              </a:defRPr>
+            </a:pPr>
+            <a:r>
+              <a:t>Most Popular is surprisingly strong in sparse data (P@10 = 0.122)</a:t>
+            </a:r>
+          </a:p>
+        </p:txBody>
+      </p:sp>
+      <p:sp>
+        <p:nvSpPr>
+          <p:cNvPr id="6" name="TextBox 5"/>
+          <p:cNvSpPr txBox="1"/>
+          <p:nvPr/>
+        </p:nvSpPr>
+        <p:spPr>
+          <a:xfrm>
+            <a:off x="914400" y="2468880"/>
+            <a:ext cx="9601200" cy="457200"/>
+          </a:xfrm>
+          <a:prstGeom prst="rect">
+            <a:avLst/>
+          </a:prstGeom>
+          <a:noFill/>
+        </p:spPr>
+        <p:txBody>
+          <a:bodyPr wrap="square">
+            <a:spAutoFit/>
+          </a:bodyPr>
+          <a:lstStyle/>
+          <a:p>
+            <a:pPr algn="l">
+              <a:defRPr sz="1600" b="0">
+                <a:solidFill>
+                  <a:srgbClr val="E5E5E5"/>
+                </a:solidFill>
+                <a:latin typeface="Calibri"/>
+              </a:defRPr>
+            </a:pPr>
+            <a:r>
+              <a:t>  -- but only 32.4% of users get a relevant hit even from best personalized method (MF)</a:t>
+            </a:r>
+          </a:p>
+        </p:txBody>
+      </p:sp>
+      <p:sp>
+        <p:nvSpPr>
+          <p:cNvPr id="7" name="TextBox 6"/>
+          <p:cNvSpPr txBox="1"/>
+          <p:nvPr/>
+        </p:nvSpPr>
+        <p:spPr>
+          <a:xfrm>
+            <a:off x="914400" y="2880360"/>
+            <a:ext cx="9601200" cy="457200"/>
+          </a:xfrm>
+          <a:prstGeom prst="rect">
+            <a:avLst/>
+          </a:prstGeom>
+          <a:noFill/>
+        </p:spPr>
+        <p:txBody>
+          <a:bodyPr wrap="square">
+            <a:spAutoFit/>
+          </a:bodyPr>
+          <a:lstStyle/>
+          <a:p>
+            <a:pPr algn="l">
+              <a:defRPr sz="1600" b="0">
+                <a:solidFill>
+                  <a:srgbClr val="E5E5E5"/>
+                </a:solidFill>
+                <a:latin typeface="Calibri"/>
+              </a:defRPr>
+            </a:pPr>
+          </a:p>
+        </p:txBody>
+      </p:sp>
+      <p:sp>
+        <p:nvSpPr>
+          <p:cNvPr id="8" name="TextBox 7"/>
+          <p:cNvSpPr txBox="1"/>
+          <p:nvPr/>
+        </p:nvSpPr>
+        <p:spPr>
+          <a:xfrm>
+            <a:off x="914400" y="3291840"/>
+            <a:ext cx="9601200" cy="457200"/>
+          </a:xfrm>
+          <a:prstGeom prst="rect">
+            <a:avLst/>
+          </a:prstGeom>
+          <a:noFill/>
+        </p:spPr>
+        <p:txBody>
+          <a:bodyPr wrap="square">
+            <a:spAutoFit/>
+          </a:bodyPr>
+          <a:lstStyle/>
+          <a:p>
+            <a:pPr algn="l">
+              <a:defRPr sz="1600" b="0">
+                <a:solidFill>
+                  <a:srgbClr val="E5E5E5"/>
+                </a:solidFill>
+                <a:latin typeface="Calibri"/>
+              </a:defRPr>
+            </a:pPr>
+            <a:r>
+              <a:t>Core insight: 'accuracy is not enough' (as lectures emphasise)</a:t>
+            </a:r>
+          </a:p>
+        </p:txBody>
+      </p:sp>
+      <p:sp>
+        <p:nvSpPr>
+          <p:cNvPr id="9" name="TextBox 8"/>
+          <p:cNvSpPr txBox="1"/>
+          <p:nvPr/>
+        </p:nvSpPr>
+        <p:spPr>
+          <a:xfrm>
+            <a:off x="914400" y="3703320"/>
+            <a:ext cx="9601200" cy="457200"/>
+          </a:xfrm>
+          <a:prstGeom prst="rect">
+            <a:avLst/>
+          </a:prstGeom>
+          <a:noFill/>
+        </p:spPr>
+        <p:txBody>
+          <a:bodyPr wrap="square">
+            <a:spAutoFit/>
+          </a:bodyPr>
+          <a:lstStyle/>
+          <a:p>
+            <a:pPr algn="l">
+              <a:defRPr sz="1600" b="0">
+                <a:solidFill>
+                  <a:srgbClr val="E5E5E5"/>
+                </a:solidFill>
+                <a:latin typeface="Calibri"/>
+              </a:defRPr>
+            </a:pPr>
+            <a:r>
+              <a:t>  -- diversity, novelty, bias, and scalability matter equally in production</a:t>
+            </a:r>
+          </a:p>
+        </p:txBody>
+      </p:sp>
+      <p:sp>
+        <p:nvSpPr>
+          <p:cNvPr id="10" name="TextBox 9"/>
+          <p:cNvSpPr txBox="1"/>
+          <p:nvPr/>
+        </p:nvSpPr>
+        <p:spPr>
+          <a:xfrm>
+            <a:off x="914400" y="4114800"/>
+            <a:ext cx="9601200" cy="457200"/>
+          </a:xfrm>
+          <a:prstGeom prst="rect">
+            <a:avLst/>
+          </a:prstGeom>
+          <a:noFill/>
+        </p:spPr>
+        <p:txBody>
+          <a:bodyPr wrap="square">
+            <a:spAutoFit/>
+          </a:bodyPr>
+          <a:lstStyle/>
+          <a:p>
+            <a:pPr algn="l">
+              <a:defRPr sz="1600" b="0">
+                <a:solidFill>
+                  <a:srgbClr val="E5E5E5"/>
+                </a:solidFill>
+                <a:latin typeface="Calibri"/>
+              </a:defRPr>
+            </a:pPr>
+            <a:r>
+              <a:t>  -- no single model dominates; ensembles are the path forward (Netflix Prize, Folie 22)</a:t>
+            </a:r>
+          </a:p>
+        </p:txBody>
+      </p:sp>
+      <p:sp>
+        <p:nvSpPr>
+          <p:cNvPr id="11" name="TextBox 10"/>
+          <p:cNvSpPr txBox="1"/>
+          <p:nvPr/>
+        </p:nvSpPr>
+        <p:spPr>
+          <a:xfrm>
+            <a:off x="914400" y="4526280"/>
+            <a:ext cx="9601200" cy="457200"/>
+          </a:xfrm>
+          <a:prstGeom prst="rect">
+            <a:avLst/>
+          </a:prstGeom>
+          <a:noFill/>
+        </p:spPr>
+        <p:txBody>
+          <a:bodyPr wrap="square">
+            <a:spAutoFit/>
+          </a:bodyPr>
+          <a:lstStyle/>
+          <a:p>
+            <a:pPr algn="l">
+              <a:defRPr sz="1600" b="0">
+                <a:solidFill>
+                  <a:srgbClr val="E5E5E5"/>
+                </a:solidFill>
+                <a:latin typeface="Calibri"/>
+              </a:defRPr>
+            </a:pPr>
+          </a:p>
+        </p:txBody>
+      </p:sp>
+      <p:sp>
+        <p:nvSpPr>
+          <p:cNvPr id="12" name="TextBox 11"/>
+          <p:cNvSpPr txBox="1"/>
+          <p:nvPr/>
+        </p:nvSpPr>
+        <p:spPr>
+          <a:xfrm>
+            <a:off x="914400" y="4937760"/>
+            <a:ext cx="9601200" cy="457200"/>
+          </a:xfrm>
+          <a:prstGeom prst="rect">
+            <a:avLst/>
+          </a:prstGeom>
+          <a:noFill/>
+        </p:spPr>
+        <p:txBody>
+          <a:bodyPr wrap="square">
+            <a:spAutoFit/>
+          </a:bodyPr>
+          <a:lstStyle/>
+          <a:p>
+            <a:pPr algn="l">
+              <a:defRPr sz="1600" b="0">
+                <a:solidFill>
+                  <a:srgbClr val="E5E5E5"/>
+                </a:solidFill>
+                <a:latin typeface="Calibri"/>
+              </a:defRPr>
+            </a:pPr>
+            <a:r>
+              <a:t>When is MF worth 20s training over 0.003s Most Popular? Only when the platform is</a:t>
+            </a:r>
+          </a:p>
+        </p:txBody>
+      </p:sp>
+      <p:sp>
+        <p:nvSpPr>
+          <p:cNvPr id="13" name="TextBox 12"/>
+          <p:cNvSpPr txBox="1"/>
+          <p:nvPr/>
+        </p:nvSpPr>
+        <p:spPr>
+          <a:xfrm>
+            <a:off x="914400" y="5349240"/>
+            <a:ext cx="9601200" cy="457200"/>
+          </a:xfrm>
+          <a:prstGeom prst="rect">
+            <a:avLst/>
+          </a:prstGeom>
+          <a:noFill/>
+        </p:spPr>
+        <p:txBody>
+          <a:bodyPr wrap="square">
+            <a:spAutoFit/>
+          </a:bodyPr>
+          <a:lstStyle/>
+          <a:p>
+            <a:pPr algn="l">
+              <a:defRPr sz="1600" b="0">
+                <a:solidFill>
+                  <a:srgbClr val="E5E5E5"/>
+                </a:solidFill>
+                <a:latin typeface="Calibri"/>
+              </a:defRPr>
+            </a:pPr>
+            <a:r>
+              <a:t>  large enough that a 5% precision lift translates to significant engagement gains</a:t>
+            </a:r>
+          </a:p>
+        </p:txBody>
+      </p:sp>
+      <p:sp>
+        <p:nvSpPr>
+          <p:cNvPr id="14" name="TextBox 13"/>
+          <p:cNvSpPr txBox="1"/>
+          <p:nvPr/>
+        </p:nvSpPr>
+        <p:spPr>
+          <a:xfrm>
+            <a:off x="914400" y="5760720"/>
+            <a:ext cx="9601200" cy="457200"/>
+          </a:xfrm>
+          <a:prstGeom prst="rect">
+            <a:avLst/>
+          </a:prstGeom>
+          <a:noFill/>
+        </p:spPr>
+        <p:txBody>
+          <a:bodyPr wrap="square">
+            <a:spAutoFit/>
+          </a:bodyPr>
+          <a:lstStyle/>
+          <a:p>
+            <a:pPr algn="l">
+              <a:defRPr sz="1600" b="0">
+                <a:solidFill>
+                  <a:srgbClr val="E5E5E5"/>
+                </a:solidFill>
+                <a:latin typeface="Calibri"/>
+              </a:defRPr>
+            </a:pPr>
+          </a:p>
+        </p:txBody>
+      </p:sp>
+      <p:sp>
+        <p:nvSpPr>
+          <p:cNvPr id="15" name="TextBox 14"/>
+          <p:cNvSpPr txBox="1"/>
+          <p:nvPr/>
+        </p:nvSpPr>
+        <p:spPr>
+          <a:xfrm>
+            <a:off x="914400" y="6172200"/>
+            <a:ext cx="9601200" cy="457200"/>
+          </a:xfrm>
+          <a:prstGeom prst="rect">
+            <a:avLst/>
+          </a:prstGeom>
+          <a:noFill/>
+        </p:spPr>
+        <p:txBody>
+          <a:bodyPr wrap="square">
+            <a:spAutoFit/>
+          </a:bodyPr>
+          <a:lstStyle/>
+          <a:p>
+            <a:pPr algn="l">
+              <a:defRPr sz="1600" b="0">
+                <a:solidFill>
+                  <a:srgbClr val="E5E5E5"/>
+                </a:solidFill>
+                <a:latin typeface="Calibri"/>
+              </a:defRPr>
+            </a:pPr>
+            <a:r>
+              <a:t>Honest limitation: at 98.3% sparsity, all methods struggle with top-N --</a:t>
+            </a:r>
+          </a:p>
+        </p:txBody>
+      </p:sp>
+      <p:sp>
+        <p:nvSpPr>
+          <p:cNvPr id="16" name="TextBox 15"/>
+          <p:cNvSpPr txBox="1"/>
+          <p:nvPr/>
+        </p:nvSpPr>
+        <p:spPr>
+          <a:xfrm>
+            <a:off x="914400" y="6583680"/>
+            <a:ext cx="9601200" cy="457200"/>
+          </a:xfrm>
+          <a:prstGeom prst="rect">
+            <a:avLst/>
+          </a:prstGeom>
+          <a:noFill/>
+        </p:spPr>
+        <p:txBody>
+          <a:bodyPr wrap="square">
+            <a:spAutoFit/>
+          </a:bodyPr>
+          <a:lstStyle/>
+          <a:p>
+            <a:pPr algn="l">
+              <a:defRPr sz="1600" b="0">
+                <a:solidFill>
+                  <a:srgbClr val="E5E5E5"/>
+                </a:solidFill>
+                <a:latin typeface="Calibri"/>
+              </a:defRPr>
+            </a:pPr>
+            <a:r>
+              <a:t>  academically rigorous, but production deployment requires hybrid extensions</a:t>
             </a:r>
           </a:p>
         </p:txBody>
@@ -5724,7 +7876,7 @@
               </a:defRPr>
             </a:pPr>
             <a:r>
-              <a:t>Goal: recommend movies a user will enjoy, from a large catalog</a:t>
+              <a:t>Goal: recommend movies a user will enjoy, from a catalog of 9,742 titles</a:t>
             </a:r>
           </a:p>
         </p:txBody>
@@ -5760,7 +7912,7 @@
               </a:defRPr>
             </a:pPr>
             <a:r>
-              <a:t>Dataset: MovieLens Latest Small (GroupLens)</a:t>
+              <a:t>Dataset: MovieLens Latest Small -- GroupLens Research (University of Minnesota)</a:t>
             </a:r>
           </a:p>
         </p:txBody>
@@ -5796,7 +7948,7 @@
               </a:defRPr>
             </a:pPr>
             <a:r>
-              <a:t>100,836 ratings  |  610 users  |  9,742 movies</a:t>
+              <a:t>  License: research &amp; educational use permitted (see dataset README)</a:t>
             </a:r>
           </a:p>
         </p:txBody>
@@ -5832,7 +7984,7 @@
               </a:defRPr>
             </a:pPr>
             <a:r>
-              <a:t>Rating scale: 0.5 -- 5.0 (half-star increments)</a:t>
+              <a:t>100,836 ratings  |  610 users  |  9,742 movies  |  0.5--5.0 scale</a:t>
             </a:r>
           </a:p>
         </p:txBody>
@@ -5868,7 +8020,7 @@
               </a:defRPr>
             </a:pPr>
             <a:r>
-              <a:t>Sparsity: 98.3% of the user-item matrix is empty</a:t>
+              <a:t>Data representation: User-Item matrix (610 x 9742), 98.3% sparse</a:t>
             </a:r>
           </a:p>
         </p:txBody>
@@ -5904,7 +8056,7 @@
               </a:defRPr>
             </a:pPr>
             <a:r>
-              <a:t>Train/Test split: 80/20 random</a:t>
+              <a:t>No filtering or sampling applied -- all raw data used as-is</a:t>
             </a:r>
           </a:p>
         </p:txBody>
@@ -5940,7 +8092,112 @@
               </a:defRPr>
             </a:pPr>
             <a:r>
-              <a:t>Challenge: extreme sparsity limits collaborative methods</a:t>
+              <a:t>Train/Test split: 80/20 random, stratified by user (random_state=42)</a:t>
+            </a:r>
+          </a:p>
+        </p:txBody>
+      </p:sp>
+      <p:sp>
+        <p:nvSpPr>
+          <p:cNvPr id="11" name="TextBox 10"/>
+          <p:cNvSpPr txBox="1"/>
+          <p:nvPr/>
+        </p:nvSpPr>
+        <p:spPr>
+          <a:xfrm>
+            <a:off x="914400" y="4526280"/>
+            <a:ext cx="9601200" cy="457200"/>
+          </a:xfrm>
+          <a:prstGeom prst="rect">
+            <a:avLst/>
+          </a:prstGeom>
+          <a:noFill/>
+        </p:spPr>
+        <p:txBody>
+          <a:bodyPr wrap="square">
+            <a:spAutoFit/>
+          </a:bodyPr>
+          <a:lstStyle/>
+          <a:p>
+            <a:pPr algn="l">
+              <a:defRPr sz="1600" b="0">
+                <a:solidFill>
+                  <a:srgbClr val="E5E5E5"/>
+                </a:solidFill>
+                <a:latin typeface="Calibri"/>
+              </a:defRPr>
+            </a:pPr>
+          </a:p>
+        </p:txBody>
+      </p:sp>
+      <p:sp>
+        <p:nvSpPr>
+          <p:cNvPr id="12" name="TextBox 11"/>
+          <p:cNvSpPr txBox="1"/>
+          <p:nvPr/>
+        </p:nvSpPr>
+        <p:spPr>
+          <a:xfrm>
+            <a:off x="914400" y="4937760"/>
+            <a:ext cx="9601200" cy="457200"/>
+          </a:xfrm>
+          <a:prstGeom prst="rect">
+            <a:avLst/>
+          </a:prstGeom>
+          <a:noFill/>
+        </p:spPr>
+        <p:txBody>
+          <a:bodyPr wrap="square">
+            <a:spAutoFit/>
+          </a:bodyPr>
+          <a:lstStyle/>
+          <a:p>
+            <a:pPr algn="l">
+              <a:defRPr sz="1600" b="0">
+                <a:solidFill>
+                  <a:srgbClr val="E5E5E5"/>
+                </a:solidFill>
+                <a:latin typeface="Calibri"/>
+              </a:defRPr>
+            </a:pPr>
+            <a:r>
+              <a:t>Same dataset, 8 algorithms: enables direct, fair method comparison</a:t>
+            </a:r>
+          </a:p>
+        </p:txBody>
+      </p:sp>
+      <p:sp>
+        <p:nvSpPr>
+          <p:cNvPr id="13" name="TextBox 12"/>
+          <p:cNvSpPr txBox="1"/>
+          <p:nvPr/>
+        </p:nvSpPr>
+        <p:spPr>
+          <a:xfrm>
+            <a:off x="914400" y="5349240"/>
+            <a:ext cx="9601200" cy="457200"/>
+          </a:xfrm>
+          <a:prstGeom prst="rect">
+            <a:avLst/>
+          </a:prstGeom>
+          <a:noFill/>
+        </p:spPr>
+        <p:txBody>
+          <a:bodyPr wrap="square">
+            <a:spAutoFit/>
+          </a:bodyPr>
+          <a:lstStyle/>
+          <a:p>
+            <a:pPr algn="l">
+              <a:defRPr sz="1600" b="0">
+                <a:solidFill>
+                  <a:srgbClr val="E5E5E5"/>
+                </a:solidFill>
+                <a:latin typeface="Calibri"/>
+              </a:defRPr>
+            </a:pPr>
+            <a:r>
+              <a:t>Agile approach: basic evaluation running from week 1, extended iteratively</a:t>
             </a:r>
           </a:p>
         </p:txBody>
@@ -6416,7 +8673,7 @@
               </a:defRPr>
             </a:pPr>
             <a:r>
-              <a:t>  -- Crowd favorites are a strong signal in sparse data</a:t>
+              <a:t>  Strength: crowd favorites are a strong signal in sparse data</a:t>
             </a:r>
           </a:p>
         </p:txBody>
@@ -6452,7 +8709,43 @@
               </a:defRPr>
             </a:pPr>
             <a:r>
-              <a:t>  -- But: 100% popularity bias, 0% serendipity, coverage &lt; 1%</a:t>
+              <a:t>  Weakness: 100% popularity bias, 0% serendipity, coverage &lt; 1%</a:t>
+            </a:r>
+          </a:p>
+        </p:txBody>
+      </p:sp>
+      <p:sp>
+        <p:nvSpPr>
+          <p:cNvPr id="12" name="TextBox 11"/>
+          <p:cNvSpPr txBox="1"/>
+          <p:nvPr/>
+        </p:nvSpPr>
+        <p:spPr>
+          <a:xfrm>
+            <a:off x="914400" y="4937760"/>
+            <a:ext cx="9601200" cy="457200"/>
+          </a:xfrm>
+          <a:prstGeom prst="rect">
+            <a:avLst/>
+          </a:prstGeom>
+          <a:noFill/>
+        </p:spPr>
+        <p:txBody>
+          <a:bodyPr wrap="square">
+            <a:spAutoFit/>
+          </a:bodyPr>
+          <a:lstStyle/>
+          <a:p>
+            <a:pPr algn="l">
+              <a:defRPr sz="1600" b="0">
+                <a:solidFill>
+                  <a:srgbClr val="E5E5E5"/>
+                </a:solidFill>
+                <a:latin typeface="Calibri"/>
+              </a:defRPr>
+            </a:pPr>
+            <a:r>
+              <a:t>  Use case: cold-start fallback when no user history is available</a:t>
             </a:r>
           </a:p>
         </p:txBody>
@@ -6806,7 +9099,7 @@
               </a:defRPr>
             </a:pPr>
             <a:r>
-              <a:t>Results: Precision@10 = 0.009  |  Coverage = 20.6%  |  Diversity = 0.09</a:t>
+              <a:t>Results: P@10 = 0.009  |  Coverage = 20.6%  |  Diversity = 0.09</a:t>
             </a:r>
           </a:p>
         </p:txBody>
@@ -6842,7 +9135,7 @@
               </a:defRPr>
             </a:pPr>
             <a:r>
-              <a:t>Low accuracy but best genre-coherent lists (low diversity = focused)</a:t>
+              <a:t>  Strength: best coverage (20.6%) and lowest pop bias (18.6%) -- good for discovery</a:t>
             </a:r>
           </a:p>
         </p:txBody>
@@ -6878,7 +9171,43 @@
               </a:defRPr>
             </a:pPr>
             <a:r>
-              <a:t>Very low popularity bias (18.6%) -- good for discovery</a:t>
+              <a:t>  Weakness: low accuracy, limited by genre granularity (only 20 genres)</a:t>
+            </a:r>
+          </a:p>
+        </p:txBody>
+      </p:sp>
+      <p:sp>
+        <p:nvSpPr>
+          <p:cNvPr id="13" name="TextBox 12"/>
+          <p:cNvSpPr txBox="1"/>
+          <p:nvPr/>
+        </p:nvSpPr>
+        <p:spPr>
+          <a:xfrm>
+            <a:off x="914400" y="5349240"/>
+            <a:ext cx="9601200" cy="457200"/>
+          </a:xfrm>
+          <a:prstGeom prst="rect">
+            <a:avLst/>
+          </a:prstGeom>
+          <a:noFill/>
+        </p:spPr>
+        <p:txBody>
+          <a:bodyPr wrap="square">
+            <a:spAutoFit/>
+          </a:bodyPr>
+          <a:lstStyle/>
+          <a:p>
+            <a:pPr algn="l">
+              <a:defRPr sz="1600" b="0">
+                <a:solidFill>
+                  <a:srgbClr val="E5E5E5"/>
+                </a:solidFill>
+                <a:latin typeface="Calibri"/>
+              </a:defRPr>
+            </a:pPr>
+            <a:r>
+              <a:t>  Use case: niche discovery, cold-start items (no ratings needed for items)</a:t>
             </a:r>
           </a:p>
         </p:txBody>
@@ -7091,7 +9420,7 @@
               </a:defRPr>
             </a:pPr>
             <a:r>
-              <a:t>  Similarity: Pearson Correlation (Folie 18)</a:t>
+              <a:t>  Similarity: Pearson Correlation (Folie 18), top-k=20 neighbours</a:t>
             </a:r>
           </a:p>
         </p:txBody>
@@ -7232,7 +9561,7 @@
               </a:defRPr>
             </a:pPr>
             <a:r>
-              <a:t>  Similarity: Adjusted Cosine (Folie 26)</a:t>
+              <a:t>  Similarity: Adjusted Cosine (Folie 26), top-k=20 neighbours</a:t>
             </a:r>
           </a:p>
         </p:txBody>
@@ -7301,7 +9630,7 @@
               </a:defRPr>
             </a:pPr>
             <a:r>
-              <a:t>Both near-zero Precision@10 due to 98.3% sparsity</a:t>
+              <a:t>  Strength: RMSE = 0.893 (User-User), highest novelty = 9.2, 0% pop bias</a:t>
             </a:r>
           </a:p>
         </p:txBody>
@@ -7337,7 +9666,7 @@
               </a:defRPr>
             </a:pPr>
             <a:r>
-              <a:t>User-User: MAE=0.678, RMSE=0.893 (rating prediction is better)</a:t>
+              <a:t>  Weakness: near-zero P@10 -- 98.3% sparsity means too few co-rated items</a:t>
             </a:r>
           </a:p>
         </p:txBody>
@@ -7373,7 +9702,7 @@
               </a:defRPr>
             </a:pPr>
             <a:r>
-              <a:t>But: highest novelty (9.2) and zero popularity bias!</a:t>
+              <a:t>  Use case: rating prediction (not top-N) on denser datasets</a:t>
             </a:r>
           </a:p>
         </p:txBody>
@@ -7760,7 +10089,7 @@
               </a:defRPr>
             </a:pPr>
             <a:r>
-              <a:t>Results: Precision@10 = 0.053  |  RMSE = 0.881  |  MAE = 0.675</a:t>
+              <a:t>Results: P@10 = 0.053  |  RMSE = 0.881  |  Hit Rate = 32.4%</a:t>
             </a:r>
           </a:p>
         </p:txBody>
@@ -7796,7 +10125,7 @@
               </a:defRPr>
             </a:pPr>
             <a:r>
-              <a:t>Best personalized method for top-N recommendation</a:t>
+              <a:t>  Strength: best personalized method (P@10 4x higher than Content-Based)</a:t>
             </a:r>
           </a:p>
         </p:txBody>
@@ -7832,7 +10161,43 @@
               </a:defRPr>
             </a:pPr>
             <a:r>
-              <a:t>Training converges: RMSE 0.86 -&gt; 0.73 over 20 epochs</a:t>
+              <a:t>  Weakness: only 32.4% of users receive at least one relevant hit</a:t>
+            </a:r>
+          </a:p>
+        </p:txBody>
+      </p:sp>
+      <p:sp>
+        <p:nvSpPr>
+          <p:cNvPr id="14" name="TextBox 13"/>
+          <p:cNvSpPr txBox="1"/>
+          <p:nvPr/>
+        </p:nvSpPr>
+        <p:spPr>
+          <a:xfrm>
+            <a:off x="914400" y="5760720"/>
+            <a:ext cx="9601200" cy="457200"/>
+          </a:xfrm>
+          <a:prstGeom prst="rect">
+            <a:avLst/>
+          </a:prstGeom>
+          <a:noFill/>
+        </p:spPr>
+        <p:txBody>
+          <a:bodyPr wrap="square">
+            <a:spAutoFit/>
+          </a:bodyPr>
+          <a:lstStyle/>
+          <a:p>
+            <a:pPr algn="l">
+              <a:defRPr sz="1600" b="0">
+                <a:solidFill>
+                  <a:srgbClr val="E5E5E5"/>
+                </a:solidFill>
+                <a:latin typeface="Calibri"/>
+              </a:defRPr>
+            </a:pPr>
+            <a:r>
+              <a:t>  Use case: personalized ranking at scale (O(n_ratings * k) per epoch)</a:t>
             </a:r>
           </a:p>
         </p:txBody>

</xml_diff>

<commit_message>
Fix bottom overflow on slides 17 and 20, condense ethics bullets
Co-Authored-By: Claude Opus 4.6 <noreply@anthropic.com>
</commit_message>
<xml_diff>
--- a/CineMatch_Presentation.pptx
+++ b/CineMatch_Presentation.pptx
@@ -5332,7 +5332,7 @@
               </a:defRPr>
             </a:pPr>
             <a:r>
-              <a:t>Filter bubbles: Content-Based has diversity of only 0.09 -- users see</a:t>
+              <a:t>Filter bubbles: Content-Based diversity = 0.09 -- users see increasingly</a:t>
             </a:r>
           </a:p>
         </p:txBody>
@@ -5368,7 +5368,7 @@
               </a:defRPr>
             </a:pPr>
             <a:r>
-              <a:t>  increasingly narrow genre profiles, limiting cultural exploration</a:t>
+              <a:t>  narrow genre profiles, limiting cultural exploration</a:t>
             </a:r>
           </a:p>
         </p:txBody>
@@ -5437,7 +5437,7 @@
               </a:defRPr>
             </a:pPr>
             <a:r>
-              <a:t>Popularity bias amplification: Most Popular (100% pop bias) surfaces</a:t>
+              <a:t>Popularity bias: Most Popular (100%) surfaces the same 60 movies to all</a:t>
             </a:r>
           </a:p>
         </p:txBody>
@@ -5473,7 +5473,7 @@
               </a:defRPr>
             </a:pPr>
             <a:r>
-              <a:t>  the same 60 movies to all users, marginalizing niche content</a:t>
+              <a:t>  users, marginalizing 99.4% of the catalog (rich-get-richer loop)</a:t>
             </a:r>
           </a:p>
         </p:txBody>
@@ -5542,7 +5542,7 @@
               </a:defRPr>
             </a:pPr>
             <a:r>
-              <a:t>Fairness: heavy raters get 2x better NDCG than light raters (Most Pop),</a:t>
+              <a:t>Fairness: heavy raters get 2x better NDCG than light raters (Most Pop gap=0.156)</a:t>
             </a:r>
           </a:p>
         </p:txBody>
@@ -5578,7 +5578,7 @@
               </a:defRPr>
             </a:pPr>
             <a:r>
-              <a:t>  disadvantaging casual users who contribute fewer ratings</a:t>
+              <a:t>Privacy: CF requires storing individual rating histories</a:t>
             </a:r>
           </a:p>
         </p:txBody>
@@ -5613,6 +5613,9 @@
                 <a:latin typeface="Calibri"/>
               </a:defRPr>
             </a:pPr>
+            <a:r>
+              <a:t>Transparency: MF latent factors are not interpretable to end users</a:t>
+            </a:r>
           </a:p>
         </p:txBody>
       </p:sp>
@@ -5647,115 +5650,7 @@
               </a:defRPr>
             </a:pPr>
             <a:r>
-              <a:t>Privacy: CF requires storing and processing individual rating histories</a:t>
-            </a:r>
-          </a:p>
-        </p:txBody>
-      </p:sp>
-      <p:sp>
-        <p:nvSpPr>
-          <p:cNvPr id="14" name="TextBox 13"/>
-          <p:cNvSpPr txBox="1"/>
-          <p:nvPr/>
-        </p:nvSpPr>
-        <p:spPr>
-          <a:xfrm>
-            <a:off x="914400" y="5760720"/>
-            <a:ext cx="9601200" cy="457200"/>
-          </a:xfrm>
-          <a:prstGeom prst="rect">
-            <a:avLst/>
-          </a:prstGeom>
-          <a:noFill/>
-        </p:spPr>
-        <p:txBody>
-          <a:bodyPr wrap="square">
-            <a:spAutoFit/>
-          </a:bodyPr>
-          <a:lstStyle/>
-          <a:p>
-            <a:pPr algn="l">
-              <a:defRPr sz="1600" b="0">
-                <a:solidFill>
-                  <a:srgbClr val="E5E5E5"/>
-                </a:solidFill>
-                <a:latin typeface="Calibri"/>
-              </a:defRPr>
-            </a:pPr>
-            <a:r>
-              <a:t>Transparency: MF latent factors are not interpretable -- users cannot</a:t>
-            </a:r>
-          </a:p>
-        </p:txBody>
-      </p:sp>
-      <p:sp>
-        <p:nvSpPr>
-          <p:cNvPr id="15" name="TextBox 14"/>
-          <p:cNvSpPr txBox="1"/>
-          <p:nvPr/>
-        </p:nvSpPr>
-        <p:spPr>
-          <a:xfrm>
-            <a:off x="914400" y="6172200"/>
-            <a:ext cx="9601200" cy="457200"/>
-          </a:xfrm>
-          <a:prstGeom prst="rect">
-            <a:avLst/>
-          </a:prstGeom>
-          <a:noFill/>
-        </p:spPr>
-        <p:txBody>
-          <a:bodyPr wrap="square">
-            <a:spAutoFit/>
-          </a:bodyPr>
-          <a:lstStyle/>
-          <a:p>
-            <a:pPr algn="l">
-              <a:defRPr sz="1600" b="0">
-                <a:solidFill>
-                  <a:srgbClr val="E5E5E5"/>
-                </a:solidFill>
-                <a:latin typeface="Calibri"/>
-              </a:defRPr>
-            </a:pPr>
-            <a:r>
-              <a:t>  understand why a recommendation was made</a:t>
-            </a:r>
-          </a:p>
-        </p:txBody>
-      </p:sp>
-      <p:sp>
-        <p:nvSpPr>
-          <p:cNvPr id="16" name="TextBox 15"/>
-          <p:cNvSpPr txBox="1"/>
-          <p:nvPr/>
-        </p:nvSpPr>
-        <p:spPr>
-          <a:xfrm>
-            <a:off x="914400" y="6583680"/>
-            <a:ext cx="9601200" cy="457200"/>
-          </a:xfrm>
-          <a:prstGeom prst="rect">
-            <a:avLst/>
-          </a:prstGeom>
-          <a:noFill/>
-        </p:spPr>
-        <p:txBody>
-          <a:bodyPr wrap="square">
-            <a:spAutoFit/>
-          </a:bodyPr>
-          <a:lstStyle/>
-          <a:p>
-            <a:pPr algn="l">
-              <a:defRPr sz="1600" b="0">
-                <a:solidFill>
-                  <a:srgbClr val="E5E5E5"/>
-                </a:solidFill>
-                <a:latin typeface="Calibri"/>
-              </a:defRPr>
-            </a:pPr>
-            <a:r>
-              <a:t>User autonomy: users have no control over recommendation logic in this prototype</a:t>
+              <a:t>User autonomy: no control over recommendation logic in this prototype</a:t>
             </a:r>
           </a:p>
         </p:txBody>
@@ -7348,7 +7243,7 @@
               </a:defRPr>
             </a:pPr>
             <a:r>
-              <a:t>Most Popular is surprisingly strong in sparse data (P@10 = 0.122)</a:t>
+              <a:t>Most Popular is surprisingly strong in sparse data (P@10 = 0.122) -- but only 32.4%</a:t>
             </a:r>
           </a:p>
         </p:txBody>
@@ -7384,7 +7279,7 @@
               </a:defRPr>
             </a:pPr>
             <a:r>
-              <a:t>  -- but only 32.4% of users get a relevant hit even from best personalized method (MF)</a:t>
+              <a:t>  of users get a relevant hit even from the best personalized method (MF)</a:t>
             </a:r>
           </a:p>
         </p:txBody>
@@ -7453,7 +7348,7 @@
               </a:defRPr>
             </a:pPr>
             <a:r>
-              <a:t>Core insight: 'accuracy is not enough' (as lectures emphasise)</a:t>
+              <a:t>'Accuracy is not enough': diversity, novelty, bias, and scalability matter equally</a:t>
             </a:r>
           </a:p>
         </p:txBody>
@@ -7489,7 +7384,7 @@
               </a:defRPr>
             </a:pPr>
             <a:r>
-              <a:t>  -- diversity, novelty, bias, and scalability matter equally in production</a:t>
+              <a:t>  No single model dominates; ensembles are the path forward (Netflix Prize, Folie 22)</a:t>
             </a:r>
           </a:p>
         </p:txBody>
@@ -7524,9 +7419,6 @@
                 <a:latin typeface="Calibri"/>
               </a:defRPr>
             </a:pPr>
-            <a:r>
-              <a:t>  -- no single model dominates; ensembles are the path forward (Netflix Prize, Folie 22)</a:t>
-            </a:r>
           </a:p>
         </p:txBody>
       </p:sp>
@@ -7560,6 +7452,9 @@
                 <a:latin typeface="Calibri"/>
               </a:defRPr>
             </a:pPr>
+            <a:r>
+              <a:t>When is MF worth 20s training over 0.003s Most Popular? Only when platform scale</a:t>
+            </a:r>
           </a:p>
         </p:txBody>
       </p:sp>
@@ -7594,7 +7489,7 @@
               </a:defRPr>
             </a:pPr>
             <a:r>
-              <a:t>When is MF worth 20s training over 0.003s Most Popular? Only when the platform is</a:t>
+              <a:t>  makes a 5% precision lift translate to significant engagement gains</a:t>
             </a:r>
           </a:p>
         </p:txBody>
@@ -7629,9 +7524,6 @@
                 <a:latin typeface="Calibri"/>
               </a:defRPr>
             </a:pPr>
-            <a:r>
-              <a:t>  large enough that a 5% precision lift translates to significant engagement gains</a:t>
-            </a:r>
           </a:p>
         </p:txBody>
       </p:sp>
@@ -7665,6 +7557,9 @@
                 <a:latin typeface="Calibri"/>
               </a:defRPr>
             </a:pPr>
+            <a:r>
+              <a:t>Honest limitation: at 98.3% sparsity all methods struggle with top-N;</a:t>
+            </a:r>
           </a:p>
         </p:txBody>
       </p:sp>
@@ -7677,42 +7572,6 @@
         <p:spPr>
           <a:xfrm>
             <a:off x="914400" y="6172200"/>
-            <a:ext cx="9601200" cy="457200"/>
-          </a:xfrm>
-          <a:prstGeom prst="rect">
-            <a:avLst/>
-          </a:prstGeom>
-          <a:noFill/>
-        </p:spPr>
-        <p:txBody>
-          <a:bodyPr wrap="square">
-            <a:spAutoFit/>
-          </a:bodyPr>
-          <a:lstStyle/>
-          <a:p>
-            <a:pPr algn="l">
-              <a:defRPr sz="1600" b="0">
-                <a:solidFill>
-                  <a:srgbClr val="E5E5E5"/>
-                </a:solidFill>
-                <a:latin typeface="Calibri"/>
-              </a:defRPr>
-            </a:pPr>
-            <a:r>
-              <a:t>Honest limitation: at 98.3% sparsity, all methods struggle with top-N --</a:t>
-            </a:r>
-          </a:p>
-        </p:txBody>
-      </p:sp>
-      <p:sp>
-        <p:nvSpPr>
-          <p:cNvPr id="16" name="TextBox 15"/>
-          <p:cNvSpPr txBox="1"/>
-          <p:nvPr/>
-        </p:nvSpPr>
-        <p:spPr>
-          <a:xfrm>
-            <a:off x="914400" y="6583680"/>
             <a:ext cx="9601200" cy="457200"/>
           </a:xfrm>
           <a:prstGeom prst="rect">

</xml_diff>